<commit_message>
fix: updated reference pptx
</commit_message>
<xml_diff>
--- a/slides/templates/reference.pptx
+++ b/slides/templates/reference.pptx
@@ -4,16 +4,13 @@
   <p:sldMasterIdLst>
     <p:sldMasterId id="2147483648" r:id="rId1"/>
   </p:sldMasterIdLst>
-  <p:notesMasterIdLst>
-    <p:notesMasterId r:id="rId6"/>
-  </p:notesMasterIdLst>
   <p:sldIdLst>
-    <p:sldId id="256" r:id="rId2"/>
-    <p:sldId id="257" r:id="rId3"/>
-    <p:sldId id="258" r:id="rId4"/>
-    <p:sldId id="259" r:id="rId5"/>
+    <p:sldId id="256" r:id="rId7"/>
+    <p:sldId id="257" r:id="rId8"/>
+    <p:sldId id="258" r:id="rId9"/>
+    <p:sldId id="259" r:id="rId10"/>
   </p:sldIdLst>
-  <p:sldSz cx="9144000" cy="5143500" type="screen16x9"/>
+  <p:sldSz cx="12188952" cy="6858000" type="screen4x3"/>
   <p:notesSz cx="6858000" cy="9144000"/>
   <p:defaultTextStyle>
     <a:defPPr>
@@ -110,579 +107,7 @@
       </a:defRPr>
     </a:lvl9pPr>
   </p:defaultTextStyle>
-  <p:extLst>
-    <p:ext uri="{EFAFB233-063F-42B5-8137-9DF3F51BA10A}">
-      <p15:sldGuideLst xmlns:p15="http://schemas.microsoft.com/office/powerpoint/2012/main">
-        <p15:guide id="1" orient="horz" pos="1620" userDrawn="1">
-          <p15:clr>
-            <a:srgbClr val="A4A3A4"/>
-          </p15:clr>
-        </p15:guide>
-        <p15:guide id="2" pos="2880" userDrawn="1">
-          <p15:clr>
-            <a:srgbClr val="A4A3A4"/>
-          </p15:clr>
-        </p15:guide>
-      </p15:sldGuideLst>
-    </p:ext>
-  </p:extLst>
 </p:presentation>
-</file>
-
-<file path=ppt/notesMasters/notesMaster1.xml><?xml version="1.0" encoding="utf-8"?>
-<p:notesMaster xmlns:a="http://schemas.openxmlformats.org/drawingml/2006/main" xmlns:r="http://schemas.openxmlformats.org/officeDocument/2006/relationships" xmlns:p="http://schemas.openxmlformats.org/presentationml/2006/main">
-  <p:cSld>
-    <p:bg>
-      <p:bgRef idx="1001">
-        <a:schemeClr val="bg1"/>
-      </p:bgRef>
-    </p:bg>
-    <p:spTree>
-      <p:nvGrpSpPr>
-        <p:cNvPr id="1" name=""/>
-        <p:cNvGrpSpPr/>
-        <p:nvPr/>
-      </p:nvGrpSpPr>
-      <p:grpSpPr>
-        <a:xfrm>
-          <a:off x="0" y="0"/>
-          <a:ext cx="0" cy="0"/>
-          <a:chOff x="0" y="0"/>
-          <a:chExt cx="0" cy="0"/>
-        </a:xfrm>
-      </p:grpSpPr>
-      <p:sp>
-        <p:nvSpPr>
-          <p:cNvPr id="2" name="Header Placeholder 1"/>
-          <p:cNvSpPr>
-            <a:spLocks noGrp="1"/>
-          </p:cNvSpPr>
-          <p:nvPr>
-            <p:ph type="hdr" sz="quarter"/>
-          </p:nvPr>
-        </p:nvSpPr>
-        <p:spPr>
-          <a:xfrm>
-            <a:off x="0" y="0"/>
-            <a:ext cx="2971800" cy="458788"/>
-          </a:xfrm>
-          <a:prstGeom prst="rect">
-            <a:avLst/>
-          </a:prstGeom>
-        </p:spPr>
-        <p:txBody>
-          <a:bodyPr vert="horz" lIns="91440" tIns="45720" rIns="91440" bIns="45720" rtlCol="0"/>
-          <a:lstStyle>
-            <a:lvl1pPr algn="l">
-              <a:defRPr sz="1200"/>
-            </a:lvl1pPr>
-          </a:lstStyle>
-          <a:p>
-            <a:endParaRPr lang="en-US"/>
-          </a:p>
-        </p:txBody>
-      </p:sp>
-      <p:sp>
-        <p:nvSpPr>
-          <p:cNvPr id="3" name="Date Placeholder 2"/>
-          <p:cNvSpPr>
-            <a:spLocks noGrp="1"/>
-          </p:cNvSpPr>
-          <p:nvPr>
-            <p:ph type="dt" idx="1"/>
-          </p:nvPr>
-        </p:nvSpPr>
-        <p:spPr>
-          <a:xfrm>
-            <a:off x="3884613" y="0"/>
-            <a:ext cx="2971800" cy="458788"/>
-          </a:xfrm>
-          <a:prstGeom prst="rect">
-            <a:avLst/>
-          </a:prstGeom>
-        </p:spPr>
-        <p:txBody>
-          <a:bodyPr vert="horz" lIns="91440" tIns="45720" rIns="91440" bIns="45720" rtlCol="0"/>
-          <a:lstStyle>
-            <a:lvl1pPr algn="r">
-              <a:defRPr sz="1200"/>
-            </a:lvl1pPr>
-          </a:lstStyle>
-          <a:p>
-            <a:fld id="{0F9C1CCF-B725-44A7-AA57-5E433BD85C9F}" type="datetimeFigureOut">
-              <a:rPr lang="en-US" smtClean="0"/>
-              <a:t>1/2/22</a:t>
-            </a:fld>
-            <a:endParaRPr lang="en-US"/>
-          </a:p>
-        </p:txBody>
-      </p:sp>
-      <p:sp>
-        <p:nvSpPr>
-          <p:cNvPr id="4" name="Slide Image Placeholder 3"/>
-          <p:cNvSpPr>
-            <a:spLocks noGrp="1" noRot="1" noChangeAspect="1"/>
-          </p:cNvSpPr>
-          <p:nvPr>
-            <p:ph type="sldImg" idx="2"/>
-          </p:nvPr>
-        </p:nvSpPr>
-        <p:spPr>
-          <a:xfrm>
-            <a:off x="685800" y="1143000"/>
-            <a:ext cx="5486400" cy="3086100"/>
-          </a:xfrm>
-          <a:prstGeom prst="rect">
-            <a:avLst/>
-          </a:prstGeom>
-          <a:noFill/>
-          <a:ln w="12700">
-            <a:solidFill>
-              <a:prstClr val="black"/>
-            </a:solidFill>
-          </a:ln>
-        </p:spPr>
-        <p:txBody>
-          <a:bodyPr vert="horz" lIns="91440" tIns="45720" rIns="91440" bIns="45720" rtlCol="0" anchor="ctr"/>
-          <a:lstStyle/>
-          <a:p>
-            <a:endParaRPr lang="en-US"/>
-          </a:p>
-        </p:txBody>
-      </p:sp>
-      <p:sp>
-        <p:nvSpPr>
-          <p:cNvPr id="5" name="Notes Placeholder 4"/>
-          <p:cNvSpPr>
-            <a:spLocks noGrp="1"/>
-          </p:cNvSpPr>
-          <p:nvPr>
-            <p:ph type="body" sz="quarter" idx="3"/>
-          </p:nvPr>
-        </p:nvSpPr>
-        <p:spPr>
-          <a:xfrm>
-            <a:off x="685800" y="4400550"/>
-            <a:ext cx="5486400" cy="3600450"/>
-          </a:xfrm>
-          <a:prstGeom prst="rect">
-            <a:avLst/>
-          </a:prstGeom>
-        </p:spPr>
-        <p:txBody>
-          <a:bodyPr vert="horz" lIns="91440" tIns="45720" rIns="91440" bIns="45720" rtlCol="0"/>
-          <a:lstStyle/>
-          <a:p>
-            <a:pPr lvl="0"/>
-            <a:r>
-              <a:rPr lang="en-US"/>
-              <a:t>Click to edit Master text styles</a:t>
-            </a:r>
-          </a:p>
-          <a:p>
-            <a:pPr lvl="1"/>
-            <a:r>
-              <a:rPr lang="en-US"/>
-              <a:t>Second level</a:t>
-            </a:r>
-          </a:p>
-          <a:p>
-            <a:pPr lvl="2"/>
-            <a:r>
-              <a:rPr lang="en-US"/>
-              <a:t>Third level</a:t>
-            </a:r>
-          </a:p>
-          <a:p>
-            <a:pPr lvl="3"/>
-            <a:r>
-              <a:rPr lang="en-US"/>
-              <a:t>Fourth level</a:t>
-            </a:r>
-          </a:p>
-          <a:p>
-            <a:pPr lvl="4"/>
-            <a:r>
-              <a:rPr lang="en-US"/>
-              <a:t>Fifth level</a:t>
-            </a:r>
-          </a:p>
-        </p:txBody>
-      </p:sp>
-      <p:sp>
-        <p:nvSpPr>
-          <p:cNvPr id="6" name="Footer Placeholder 5"/>
-          <p:cNvSpPr>
-            <a:spLocks noGrp="1"/>
-          </p:cNvSpPr>
-          <p:nvPr>
-            <p:ph type="ftr" sz="quarter" idx="4"/>
-          </p:nvPr>
-        </p:nvSpPr>
-        <p:spPr>
-          <a:xfrm>
-            <a:off x="0" y="8685213"/>
-            <a:ext cx="2971800" cy="458787"/>
-          </a:xfrm>
-          <a:prstGeom prst="rect">
-            <a:avLst/>
-          </a:prstGeom>
-        </p:spPr>
-        <p:txBody>
-          <a:bodyPr vert="horz" lIns="91440" tIns="45720" rIns="91440" bIns="45720" rtlCol="0" anchor="b"/>
-          <a:lstStyle>
-            <a:lvl1pPr algn="l">
-              <a:defRPr sz="1200"/>
-            </a:lvl1pPr>
-          </a:lstStyle>
-          <a:p>
-            <a:endParaRPr lang="en-US"/>
-          </a:p>
-        </p:txBody>
-      </p:sp>
-      <p:sp>
-        <p:nvSpPr>
-          <p:cNvPr id="7" name="Slide Number Placeholder 6"/>
-          <p:cNvSpPr>
-            <a:spLocks noGrp="1"/>
-          </p:cNvSpPr>
-          <p:nvPr>
-            <p:ph type="sldNum" sz="quarter" idx="5"/>
-          </p:nvPr>
-        </p:nvSpPr>
-        <p:spPr>
-          <a:xfrm>
-            <a:off x="3884613" y="8685213"/>
-            <a:ext cx="2971800" cy="458787"/>
-          </a:xfrm>
-          <a:prstGeom prst="rect">
-            <a:avLst/>
-          </a:prstGeom>
-        </p:spPr>
-        <p:txBody>
-          <a:bodyPr vert="horz" lIns="91440" tIns="45720" rIns="91440" bIns="45720" rtlCol="0" anchor="b"/>
-          <a:lstStyle>
-            <a:lvl1pPr algn="r">
-              <a:defRPr sz="1200"/>
-            </a:lvl1pPr>
-          </a:lstStyle>
-          <a:p>
-            <a:fld id="{18BDFEC3-8487-43E8-A154-7C12CBC1FFF2}" type="slidenum">
-              <a:rPr lang="en-US" smtClean="0"/>
-              <a:t>‹#›</a:t>
-            </a:fld>
-            <a:endParaRPr lang="en-US"/>
-          </a:p>
-        </p:txBody>
-      </p:sp>
-    </p:spTree>
-    <p:extLst>
-      <p:ext uri="{BB962C8B-B14F-4D97-AF65-F5344CB8AC3E}">
-        <p14:creationId xmlns:p14="http://schemas.microsoft.com/office/powerpoint/2010/main" val="3782709779"/>
-      </p:ext>
-    </p:extLst>
-  </p:cSld>
-  <p:clrMap bg1="lt1" tx1="dk1" bg2="lt2" tx2="dk2" accent1="accent1" accent2="accent2" accent3="accent3" accent4="accent4" accent5="accent5" accent6="accent6" hlink="hlink" folHlink="folHlink"/>
-  <p:notesStyle>
-    <a:lvl1pPr marL="0" algn="l" defTabSz="914400" rtl="0" eaLnBrk="1" latinLnBrk="0" hangingPunct="1">
-      <a:defRPr sz="1200" kern="1200">
-        <a:solidFill>
-          <a:schemeClr val="tx1"/>
-        </a:solidFill>
-        <a:latin typeface="+mn-lt"/>
-        <a:ea typeface="+mn-ea"/>
-        <a:cs typeface="+mn-cs"/>
-      </a:defRPr>
-    </a:lvl1pPr>
-    <a:lvl2pPr marL="457200" algn="l" defTabSz="914400" rtl="0" eaLnBrk="1" latinLnBrk="0" hangingPunct="1">
-      <a:defRPr sz="1200" kern="1200">
-        <a:solidFill>
-          <a:schemeClr val="tx1"/>
-        </a:solidFill>
-        <a:latin typeface="+mn-lt"/>
-        <a:ea typeface="+mn-ea"/>
-        <a:cs typeface="+mn-cs"/>
-      </a:defRPr>
-    </a:lvl2pPr>
-    <a:lvl3pPr marL="914400" algn="l" defTabSz="914400" rtl="0" eaLnBrk="1" latinLnBrk="0" hangingPunct="1">
-      <a:defRPr sz="1200" kern="1200">
-        <a:solidFill>
-          <a:schemeClr val="tx1"/>
-        </a:solidFill>
-        <a:latin typeface="+mn-lt"/>
-        <a:ea typeface="+mn-ea"/>
-        <a:cs typeface="+mn-cs"/>
-      </a:defRPr>
-    </a:lvl3pPr>
-    <a:lvl4pPr marL="1371600" algn="l" defTabSz="914400" rtl="0" eaLnBrk="1" latinLnBrk="0" hangingPunct="1">
-      <a:defRPr sz="1200" kern="1200">
-        <a:solidFill>
-          <a:schemeClr val="tx1"/>
-        </a:solidFill>
-        <a:latin typeface="+mn-lt"/>
-        <a:ea typeface="+mn-ea"/>
-        <a:cs typeface="+mn-cs"/>
-      </a:defRPr>
-    </a:lvl4pPr>
-    <a:lvl5pPr marL="1828800" algn="l" defTabSz="914400" rtl="0" eaLnBrk="1" latinLnBrk="0" hangingPunct="1">
-      <a:defRPr sz="1200" kern="1200">
-        <a:solidFill>
-          <a:schemeClr val="tx1"/>
-        </a:solidFill>
-        <a:latin typeface="+mn-lt"/>
-        <a:ea typeface="+mn-ea"/>
-        <a:cs typeface="+mn-cs"/>
-      </a:defRPr>
-    </a:lvl5pPr>
-    <a:lvl6pPr marL="2286000" algn="l" defTabSz="914400" rtl="0" eaLnBrk="1" latinLnBrk="0" hangingPunct="1">
-      <a:defRPr sz="1200" kern="1200">
-        <a:solidFill>
-          <a:schemeClr val="tx1"/>
-        </a:solidFill>
-        <a:latin typeface="+mn-lt"/>
-        <a:ea typeface="+mn-ea"/>
-        <a:cs typeface="+mn-cs"/>
-      </a:defRPr>
-    </a:lvl6pPr>
-    <a:lvl7pPr marL="2743200" algn="l" defTabSz="914400" rtl="0" eaLnBrk="1" latinLnBrk="0" hangingPunct="1">
-      <a:defRPr sz="1200" kern="1200">
-        <a:solidFill>
-          <a:schemeClr val="tx1"/>
-        </a:solidFill>
-        <a:latin typeface="+mn-lt"/>
-        <a:ea typeface="+mn-ea"/>
-        <a:cs typeface="+mn-cs"/>
-      </a:defRPr>
-    </a:lvl7pPr>
-    <a:lvl8pPr marL="3200400" algn="l" defTabSz="914400" rtl="0" eaLnBrk="1" latinLnBrk="0" hangingPunct="1">
-      <a:defRPr sz="1200" kern="1200">
-        <a:solidFill>
-          <a:schemeClr val="tx1"/>
-        </a:solidFill>
-        <a:latin typeface="+mn-lt"/>
-        <a:ea typeface="+mn-ea"/>
-        <a:cs typeface="+mn-cs"/>
-      </a:defRPr>
-    </a:lvl8pPr>
-    <a:lvl9pPr marL="3657600" algn="l" defTabSz="914400" rtl="0" eaLnBrk="1" latinLnBrk="0" hangingPunct="1">
-      <a:defRPr sz="1200" kern="1200">
-        <a:solidFill>
-          <a:schemeClr val="tx1"/>
-        </a:solidFill>
-        <a:latin typeface="+mn-lt"/>
-        <a:ea typeface="+mn-ea"/>
-        <a:cs typeface="+mn-cs"/>
-      </a:defRPr>
-    </a:lvl9pPr>
-  </p:notesStyle>
-</p:notesMaster>
-</file>
-
-<file path=ppt/notesSlides/notesSlide1.xml><?xml version="1.0" encoding="utf-8"?>
-<p:notes xmlns:a="http://schemas.openxmlformats.org/drawingml/2006/main" xmlns:r="http://schemas.openxmlformats.org/officeDocument/2006/relationships" xmlns:p="http://schemas.openxmlformats.org/presentationml/2006/main">
-  <p:cSld>
-    <p:spTree>
-      <p:nvGrpSpPr>
-        <p:cNvPr id="1" name=""/>
-        <p:cNvGrpSpPr/>
-        <p:nvPr/>
-      </p:nvGrpSpPr>
-      <p:grpSpPr>
-        <a:xfrm>
-          <a:off x="0" y="0"/>
-          <a:ext cx="0" cy="0"/>
-          <a:chOff x="0" y="0"/>
-          <a:chExt cx="0" cy="0"/>
-        </a:xfrm>
-      </p:grpSpPr>
-      <p:sp>
-        <p:nvSpPr>
-          <p:cNvPr id="2" name="Slide Image Placeholder 1"/>
-          <p:cNvSpPr>
-            <a:spLocks noGrp="1" noRot="1" noChangeAspect="1"/>
-          </p:cNvSpPr>
-          <p:nvPr>
-            <p:ph type="sldImg"/>
-          </p:nvPr>
-        </p:nvSpPr>
-        <p:spPr>
-          <a:xfrm>
-            <a:off x="685800" y="1143000"/>
-            <a:ext cx="5486400" cy="3086100"/>
-          </a:xfrm>
-        </p:spPr>
-      </p:sp>
-      <p:sp>
-        <p:nvSpPr>
-          <p:cNvPr id="3" name="Notes Placeholder 2"/>
-          <p:cNvSpPr>
-            <a:spLocks noGrp="1"/>
-          </p:cNvSpPr>
-          <p:nvPr>
-            <p:ph type="body" idx="1"/>
-          </p:nvPr>
-        </p:nvSpPr>
-        <p:spPr/>
-        <p:txBody>
-          <a:bodyPr/>
-          <a:lstStyle/>
-          <a:p>
-            <a:r>
-              <a:rPr lang="en-US" dirty="0"/>
-              <a:t>Here</a:t>
-            </a:r>
-            <a:r>
-              <a:rPr lang="en-US" baseline="0" dirty="0"/>
-              <a:t> is a note</a:t>
-            </a:r>
-          </a:p>
-          <a:p>
-            <a:endParaRPr lang="en-US" baseline="0" dirty="0"/>
-          </a:p>
-          <a:p>
-            <a:r>
-              <a:rPr lang="en-US" baseline="0" dirty="0"/>
-              <a:t>With another paragraph.</a:t>
-            </a:r>
-            <a:endParaRPr lang="en-US" dirty="0"/>
-          </a:p>
-        </p:txBody>
-      </p:sp>
-      <p:sp>
-        <p:nvSpPr>
-          <p:cNvPr id="4" name="Slide Number Placeholder 3"/>
-          <p:cNvSpPr>
-            <a:spLocks noGrp="1"/>
-          </p:cNvSpPr>
-          <p:nvPr>
-            <p:ph type="sldNum" sz="quarter" idx="10"/>
-          </p:nvPr>
-        </p:nvSpPr>
-        <p:spPr/>
-        <p:txBody>
-          <a:bodyPr/>
-          <a:lstStyle/>
-          <a:p>
-            <a:fld id="{18BDFEC3-8487-43E8-A154-7C12CBC1FFF2}" type="slidenum">
-              <a:rPr lang="en-US" smtClean="0"/>
-              <a:t>1</a:t>
-            </a:fld>
-            <a:endParaRPr lang="en-US"/>
-          </a:p>
-        </p:txBody>
-      </p:sp>
-    </p:spTree>
-    <p:extLst>
-      <p:ext uri="{BB962C8B-B14F-4D97-AF65-F5344CB8AC3E}">
-        <p14:creationId xmlns:p14="http://schemas.microsoft.com/office/powerpoint/2010/main" val="3171319170"/>
-      </p:ext>
-    </p:extLst>
-  </p:cSld>
-  <p:clrMapOvr>
-    <a:masterClrMapping/>
-  </p:clrMapOvr>
-</p:notes>
-</file>
-
-<file path=ppt/notesSlides/notesSlide2.xml><?xml version="1.0" encoding="utf-8"?>
-<p:notes xmlns:a="http://schemas.openxmlformats.org/drawingml/2006/main" xmlns:r="http://schemas.openxmlformats.org/officeDocument/2006/relationships" xmlns:p="http://schemas.openxmlformats.org/presentationml/2006/main">
-  <p:cSld>
-    <p:spTree>
-      <p:nvGrpSpPr>
-        <p:cNvPr id="1" name=""/>
-        <p:cNvGrpSpPr/>
-        <p:nvPr/>
-      </p:nvGrpSpPr>
-      <p:grpSpPr>
-        <a:xfrm>
-          <a:off x="0" y="0"/>
-          <a:ext cx="0" cy="0"/>
-          <a:chOff x="0" y="0"/>
-          <a:chExt cx="0" cy="0"/>
-        </a:xfrm>
-      </p:grpSpPr>
-      <p:sp>
-        <p:nvSpPr>
-          <p:cNvPr id="2" name="Slide Image Placeholder 1"/>
-          <p:cNvSpPr>
-            <a:spLocks noGrp="1" noRot="1" noChangeAspect="1"/>
-          </p:cNvSpPr>
-          <p:nvPr>
-            <p:ph type="sldImg"/>
-          </p:nvPr>
-        </p:nvSpPr>
-        <p:spPr>
-          <a:xfrm>
-            <a:off x="685800" y="1143000"/>
-            <a:ext cx="5486400" cy="3086100"/>
-          </a:xfrm>
-        </p:spPr>
-      </p:sp>
-      <p:sp>
-        <p:nvSpPr>
-          <p:cNvPr id="3" name="Notes Placeholder 2"/>
-          <p:cNvSpPr>
-            <a:spLocks noGrp="1"/>
-          </p:cNvSpPr>
-          <p:nvPr>
-            <p:ph type="body" idx="1"/>
-          </p:nvPr>
-        </p:nvSpPr>
-        <p:spPr/>
-        <p:txBody>
-          <a:bodyPr/>
-          <a:lstStyle/>
-          <a:p>
-            <a:r>
-              <a:rPr lang="en-US" dirty="0"/>
-              <a:t>A</a:t>
-            </a:r>
-            <a:r>
-              <a:rPr lang="en-US" baseline="0" dirty="0"/>
-              <a:t> speaker note on </a:t>
-            </a:r>
-            <a:r>
-              <a:rPr lang="en-US" baseline="0"/>
-              <a:t>this slide too.</a:t>
-            </a:r>
-            <a:endParaRPr lang="en-US"/>
-          </a:p>
-        </p:txBody>
-      </p:sp>
-      <p:sp>
-        <p:nvSpPr>
-          <p:cNvPr id="4" name="Slide Number Placeholder 3"/>
-          <p:cNvSpPr>
-            <a:spLocks noGrp="1"/>
-          </p:cNvSpPr>
-          <p:nvPr>
-            <p:ph type="sldNum" sz="quarter" idx="10"/>
-          </p:nvPr>
-        </p:nvSpPr>
-        <p:spPr/>
-        <p:txBody>
-          <a:bodyPr/>
-          <a:lstStyle/>
-          <a:p>
-            <a:fld id="{18BDFEC3-8487-43E8-A154-7C12CBC1FFF2}" type="slidenum">
-              <a:rPr lang="en-US" smtClean="0"/>
-              <a:t>2</a:t>
-            </a:fld>
-            <a:endParaRPr lang="en-US"/>
-          </a:p>
-        </p:txBody>
-      </p:sp>
-    </p:spTree>
-    <p:extLst>
-      <p:ext uri="{BB962C8B-B14F-4D97-AF65-F5344CB8AC3E}">
-        <p14:creationId xmlns:p14="http://schemas.microsoft.com/office/powerpoint/2010/main" val="3016900036"/>
-      </p:ext>
-    </p:extLst>
-  </p:cSld>
-  <p:clrMapOvr>
-    <a:masterClrMapping/>
-  </p:clrMapOvr>
-</p:notes>
 </file>
 
 <file path=ppt/slideLayouts/slideLayout1.xml><?xml version="1.0" encoding="utf-8"?>
@@ -714,8 +139,8 @@
         </p:nvSpPr>
         <p:spPr>
           <a:xfrm>
-            <a:off x="685800" y="1597819"/>
-            <a:ext cx="7772400" cy="1102519"/>
+            <a:off x="685800" y="2130425"/>
+            <a:ext cx="7772400" cy="1470025"/>
           </a:xfrm>
         </p:spPr>
         <p:txBody>
@@ -723,9 +148,10 @@
           <a:lstStyle/>
           <a:p>
             <a:r>
-              <a:rPr lang="en-US"/>
+              <a:rPr lang="en-US" smtClean="0"/>
               <a:t>Click to edit Master title style</a:t>
             </a:r>
+            <a:endParaRPr lang="en-US"/>
           </a:p>
         </p:txBody>
       </p:sp>
@@ -741,8 +167,8 @@
         </p:nvSpPr>
         <p:spPr>
           <a:xfrm>
-            <a:off x="1371600" y="2914650"/>
-            <a:ext cx="6400800" cy="1314450"/>
+            <a:off x="1371600" y="3886200"/>
+            <a:ext cx="6400800" cy="1752600"/>
           </a:xfrm>
         </p:spPr>
         <p:txBody>
@@ -758,7 +184,7 @@
                 </a:solidFill>
               </a:defRPr>
             </a:lvl1pPr>
-            <a:lvl2pPr marL="342900" indent="0" algn="ctr">
+            <a:lvl2pPr marL="457200" indent="0" algn="ctr">
               <a:buNone/>
               <a:defRPr>
                 <a:solidFill>
@@ -768,7 +194,7 @@
                 </a:solidFill>
               </a:defRPr>
             </a:lvl2pPr>
-            <a:lvl3pPr marL="685800" indent="0" algn="ctr">
+            <a:lvl3pPr marL="914400" indent="0" algn="ctr">
               <a:buNone/>
               <a:defRPr>
                 <a:solidFill>
@@ -778,7 +204,7 @@
                 </a:solidFill>
               </a:defRPr>
             </a:lvl3pPr>
-            <a:lvl4pPr marL="1028700" indent="0" algn="ctr">
+            <a:lvl4pPr marL="1371600" indent="0" algn="ctr">
               <a:buNone/>
               <a:defRPr>
                 <a:solidFill>
@@ -788,7 +214,7 @@
                 </a:solidFill>
               </a:defRPr>
             </a:lvl4pPr>
-            <a:lvl5pPr marL="1371600" indent="0" algn="ctr">
+            <a:lvl5pPr marL="1828800" indent="0" algn="ctr">
               <a:buNone/>
               <a:defRPr>
                 <a:solidFill>
@@ -798,7 +224,7 @@
                 </a:solidFill>
               </a:defRPr>
             </a:lvl5pPr>
-            <a:lvl6pPr marL="1714500" indent="0" algn="ctr">
+            <a:lvl6pPr marL="2286000" indent="0" algn="ctr">
               <a:buNone/>
               <a:defRPr>
                 <a:solidFill>
@@ -808,7 +234,7 @@
                 </a:solidFill>
               </a:defRPr>
             </a:lvl6pPr>
-            <a:lvl7pPr marL="2057400" indent="0" algn="ctr">
+            <a:lvl7pPr marL="2743200" indent="0" algn="ctr">
               <a:buNone/>
               <a:defRPr>
                 <a:solidFill>
@@ -818,7 +244,7 @@
                 </a:solidFill>
               </a:defRPr>
             </a:lvl7pPr>
-            <a:lvl8pPr marL="2400300" indent="0" algn="ctr">
+            <a:lvl8pPr marL="3200400" indent="0" algn="ctr">
               <a:buNone/>
               <a:defRPr>
                 <a:solidFill>
@@ -828,7 +254,7 @@
                 </a:solidFill>
               </a:defRPr>
             </a:lvl8pPr>
-            <a:lvl9pPr marL="2743200" indent="0" algn="ctr">
+            <a:lvl9pPr marL="3657600" indent="0" algn="ctr">
               <a:buNone/>
               <a:defRPr>
                 <a:solidFill>
@@ -841,9 +267,10 @@
           </a:lstStyle>
           <a:p>
             <a:r>
-              <a:rPr lang="en-US"/>
+              <a:rPr lang="en-US" smtClean="0"/>
               <a:t>Click to edit Master subtitle style</a:t>
             </a:r>
+            <a:endParaRPr lang="en-US"/>
           </a:p>
         </p:txBody>
       </p:sp>
@@ -862,9 +289,9 @@
           <a:bodyPr/>
           <a:lstStyle/>
           <a:p>
-            <a:fld id="{241EB5C9-1307-BA42-ABA2-0BC069CD8E7F}" type="datetimeFigureOut">
-              <a:rPr lang="en-US" smtClean="0"/>
-              <a:t>1/2/22</a:t>
+            <a:fld id="{5BCAD085-E8A6-8845-BD4E-CB4CCA059FC4}" type="datetimeFigureOut">
+              <a:rPr lang="en-US" smtClean="0"/>
+              <a:t>1/27/13</a:t>
             </a:fld>
             <a:endParaRPr lang="en-US"/>
           </a:p>
@@ -904,7 +331,7 @@
           <a:bodyPr/>
           <a:lstStyle/>
           <a:p>
-            <a:fld id="{C5EF2332-01BF-834F-8236-50238282D533}" type="slidenum">
+            <a:fld id="{C1FF6DA9-008F-8B48-92A6-B652298478BF}" type="slidenum">
               <a:rPr lang="en-US" smtClean="0"/>
               <a:t>‹#›</a:t>
             </a:fld>
@@ -915,7 +342,7 @@
     </p:spTree>
     <p:extLst>
       <p:ext uri="{BB962C8B-B14F-4D97-AF65-F5344CB8AC3E}">
-        <p14:creationId xmlns:p14="http://schemas.microsoft.com/office/powerpoint/2010/main" val="1444357513"/>
+        <p14:creationId xmlns:p14="http://schemas.microsoft.com/office/powerpoint/2010/main" val="3168075583"/>
       </p:ext>
     </p:extLst>
   </p:cSld>
@@ -958,9 +385,10 @@
           <a:lstStyle/>
           <a:p>
             <a:r>
-              <a:rPr lang="en-US"/>
+              <a:rPr lang="en-US" smtClean="0"/>
               <a:t>Click to edit Master title style</a:t>
             </a:r>
+            <a:endParaRPr lang="en-US"/>
           </a:p>
         </p:txBody>
       </p:sp>
@@ -981,37 +409,38 @@
           <a:p>
             <a:pPr lvl="0"/>
             <a:r>
-              <a:rPr lang="en-US"/>
+              <a:rPr lang="en-US" smtClean="0"/>
               <a:t>Click to edit Master text styles</a:t>
             </a:r>
           </a:p>
           <a:p>
             <a:pPr lvl="1"/>
             <a:r>
-              <a:rPr lang="en-US"/>
+              <a:rPr lang="en-US" smtClean="0"/>
               <a:t>Second level</a:t>
             </a:r>
           </a:p>
           <a:p>
             <a:pPr lvl="2"/>
             <a:r>
-              <a:rPr lang="en-US"/>
+              <a:rPr lang="en-US" smtClean="0"/>
               <a:t>Third level</a:t>
             </a:r>
           </a:p>
           <a:p>
             <a:pPr lvl="3"/>
             <a:r>
-              <a:rPr lang="en-US"/>
+              <a:rPr lang="en-US" smtClean="0"/>
               <a:t>Fourth level</a:t>
             </a:r>
           </a:p>
           <a:p>
             <a:pPr lvl="4"/>
             <a:r>
-              <a:rPr lang="en-US"/>
+              <a:rPr lang="en-US" smtClean="0"/>
               <a:t>Fifth level</a:t>
             </a:r>
+            <a:endParaRPr lang="en-US"/>
           </a:p>
         </p:txBody>
       </p:sp>
@@ -1030,9 +459,9 @@
           <a:bodyPr/>
           <a:lstStyle/>
           <a:p>
-            <a:fld id="{241EB5C9-1307-BA42-ABA2-0BC069CD8E7F}" type="datetimeFigureOut">
-              <a:rPr lang="en-US" smtClean="0"/>
-              <a:t>1/2/22</a:t>
+            <a:fld id="{5BCAD085-E8A6-8845-BD4E-CB4CCA059FC4}" type="datetimeFigureOut">
+              <a:rPr lang="en-US" smtClean="0"/>
+              <a:t>1/27/13</a:t>
             </a:fld>
             <a:endParaRPr lang="en-US"/>
           </a:p>
@@ -1072,7 +501,7 @@
           <a:bodyPr/>
           <a:lstStyle/>
           <a:p>
-            <a:fld id="{C5EF2332-01BF-834F-8236-50238282D533}" type="slidenum">
+            <a:fld id="{C1FF6DA9-008F-8B48-92A6-B652298478BF}" type="slidenum">
               <a:rPr lang="en-US" smtClean="0"/>
               <a:t>‹#›</a:t>
             </a:fld>
@@ -1083,7 +512,7 @@
     </p:spTree>
     <p:extLst>
       <p:ext uri="{BB962C8B-B14F-4D97-AF65-F5344CB8AC3E}">
-        <p14:creationId xmlns:p14="http://schemas.microsoft.com/office/powerpoint/2010/main" val="313914798"/>
+        <p14:creationId xmlns:p14="http://schemas.microsoft.com/office/powerpoint/2010/main" val="2910927964"/>
       </p:ext>
     </p:extLst>
   </p:cSld>
@@ -1122,8 +551,8 @@
         </p:nvSpPr>
         <p:spPr>
           <a:xfrm>
-            <a:off x="6629400" y="205979"/>
-            <a:ext cx="2057400" cy="4388644"/>
+            <a:off x="6629400" y="274638"/>
+            <a:ext cx="2057400" cy="5851525"/>
           </a:xfrm>
         </p:spPr>
         <p:txBody>
@@ -1131,9 +560,10 @@
           <a:lstStyle/>
           <a:p>
             <a:r>
-              <a:rPr lang="en-US"/>
+              <a:rPr lang="en-US" smtClean="0"/>
               <a:t>Click to edit Master title style</a:t>
             </a:r>
+            <a:endParaRPr lang="en-US"/>
           </a:p>
         </p:txBody>
       </p:sp>
@@ -1149,8 +579,8 @@
         </p:nvSpPr>
         <p:spPr>
           <a:xfrm>
-            <a:off x="457200" y="205979"/>
-            <a:ext cx="6019800" cy="4388644"/>
+            <a:off x="457200" y="274638"/>
+            <a:ext cx="6019800" cy="5851525"/>
           </a:xfrm>
         </p:spPr>
         <p:txBody>
@@ -1159,37 +589,38 @@
           <a:p>
             <a:pPr lvl="0"/>
             <a:r>
-              <a:rPr lang="en-US"/>
+              <a:rPr lang="en-US" smtClean="0"/>
               <a:t>Click to edit Master text styles</a:t>
             </a:r>
           </a:p>
           <a:p>
             <a:pPr lvl="1"/>
             <a:r>
-              <a:rPr lang="en-US"/>
+              <a:rPr lang="en-US" smtClean="0"/>
               <a:t>Second level</a:t>
             </a:r>
           </a:p>
           <a:p>
             <a:pPr lvl="2"/>
             <a:r>
-              <a:rPr lang="en-US"/>
+              <a:rPr lang="en-US" smtClean="0"/>
               <a:t>Third level</a:t>
             </a:r>
           </a:p>
           <a:p>
             <a:pPr lvl="3"/>
             <a:r>
-              <a:rPr lang="en-US"/>
+              <a:rPr lang="en-US" smtClean="0"/>
               <a:t>Fourth level</a:t>
             </a:r>
           </a:p>
           <a:p>
             <a:pPr lvl="4"/>
             <a:r>
-              <a:rPr lang="en-US"/>
+              <a:rPr lang="en-US" smtClean="0"/>
               <a:t>Fifth level</a:t>
             </a:r>
+            <a:endParaRPr lang="en-US"/>
           </a:p>
         </p:txBody>
       </p:sp>
@@ -1208,9 +639,9 @@
           <a:bodyPr/>
           <a:lstStyle/>
           <a:p>
-            <a:fld id="{241EB5C9-1307-BA42-ABA2-0BC069CD8E7F}" type="datetimeFigureOut">
-              <a:rPr lang="en-US" smtClean="0"/>
-              <a:t>1/2/22</a:t>
+            <a:fld id="{5BCAD085-E8A6-8845-BD4E-CB4CCA059FC4}" type="datetimeFigureOut">
+              <a:rPr lang="en-US" smtClean="0"/>
+              <a:t>1/27/13</a:t>
             </a:fld>
             <a:endParaRPr lang="en-US"/>
           </a:p>
@@ -1250,7 +681,7 @@
           <a:bodyPr/>
           <a:lstStyle/>
           <a:p>
-            <a:fld id="{C5EF2332-01BF-834F-8236-50238282D533}" type="slidenum">
+            <a:fld id="{C1FF6DA9-008F-8B48-92A6-B652298478BF}" type="slidenum">
               <a:rPr lang="en-US" smtClean="0"/>
               <a:t>‹#›</a:t>
             </a:fld>
@@ -1261,7 +692,7 @@
     </p:spTree>
     <p:extLst>
       <p:ext uri="{BB962C8B-B14F-4D97-AF65-F5344CB8AC3E}">
-        <p14:creationId xmlns:p14="http://schemas.microsoft.com/office/powerpoint/2010/main" val="2581529045"/>
+        <p14:creationId xmlns:p14="http://schemas.microsoft.com/office/powerpoint/2010/main" val="3612223792"/>
       </p:ext>
     </p:extLst>
   </p:cSld>
@@ -1304,9 +735,10 @@
           <a:lstStyle/>
           <a:p>
             <a:r>
-              <a:rPr lang="en-US"/>
+              <a:rPr lang="en-US" smtClean="0"/>
               <a:t>Click to edit Master title style</a:t>
             </a:r>
+            <a:endParaRPr lang="en-US"/>
           </a:p>
         </p:txBody>
       </p:sp>
@@ -1327,37 +759,38 @@
           <a:p>
             <a:pPr lvl="0"/>
             <a:r>
-              <a:rPr lang="en-US"/>
+              <a:rPr lang="en-US" smtClean="0"/>
               <a:t>Click to edit Master text styles</a:t>
             </a:r>
           </a:p>
           <a:p>
             <a:pPr lvl="1"/>
             <a:r>
-              <a:rPr lang="en-US"/>
+              <a:rPr lang="en-US" smtClean="0"/>
               <a:t>Second level</a:t>
             </a:r>
           </a:p>
           <a:p>
             <a:pPr lvl="2"/>
             <a:r>
-              <a:rPr lang="en-US"/>
+              <a:rPr lang="en-US" smtClean="0"/>
               <a:t>Third level</a:t>
             </a:r>
           </a:p>
           <a:p>
             <a:pPr lvl="3"/>
             <a:r>
-              <a:rPr lang="en-US"/>
+              <a:rPr lang="en-US" smtClean="0"/>
               <a:t>Fourth level</a:t>
             </a:r>
           </a:p>
           <a:p>
             <a:pPr lvl="4"/>
             <a:r>
-              <a:rPr lang="en-US"/>
+              <a:rPr lang="en-US" smtClean="0"/>
               <a:t>Fifth level</a:t>
             </a:r>
+            <a:endParaRPr lang="en-US"/>
           </a:p>
         </p:txBody>
       </p:sp>
@@ -1376,9 +809,9 @@
           <a:bodyPr/>
           <a:lstStyle/>
           <a:p>
-            <a:fld id="{241EB5C9-1307-BA42-ABA2-0BC069CD8E7F}" type="datetimeFigureOut">
-              <a:rPr lang="en-US" smtClean="0"/>
-              <a:t>1/2/22</a:t>
+            <a:fld id="{5BCAD085-E8A6-8845-BD4E-CB4CCA059FC4}" type="datetimeFigureOut">
+              <a:rPr lang="en-US" smtClean="0"/>
+              <a:t>1/27/13</a:t>
             </a:fld>
             <a:endParaRPr lang="en-US"/>
           </a:p>
@@ -1418,7 +851,7 @@
           <a:bodyPr/>
           <a:lstStyle/>
           <a:p>
-            <a:fld id="{C5EF2332-01BF-834F-8236-50238282D533}" type="slidenum">
+            <a:fld id="{C1FF6DA9-008F-8B48-92A6-B652298478BF}" type="slidenum">
               <a:rPr lang="en-US" smtClean="0"/>
               <a:t>‹#›</a:t>
             </a:fld>
@@ -1429,7 +862,7 @@
     </p:spTree>
     <p:extLst>
       <p:ext uri="{BB962C8B-B14F-4D97-AF65-F5344CB8AC3E}">
-        <p14:creationId xmlns:p14="http://schemas.microsoft.com/office/powerpoint/2010/main" val="338346009"/>
+        <p14:creationId xmlns:p14="http://schemas.microsoft.com/office/powerpoint/2010/main" val="2614314258"/>
       </p:ext>
     </p:extLst>
   </p:cSld>
@@ -1468,22 +901,23 @@
         </p:nvSpPr>
         <p:spPr>
           <a:xfrm>
-            <a:off x="722313" y="3305176"/>
-            <a:ext cx="7772400" cy="1021556"/>
+            <a:off x="722313" y="4406900"/>
+            <a:ext cx="7772400" cy="1362075"/>
           </a:xfrm>
         </p:spPr>
         <p:txBody>
           <a:bodyPr anchor="t"/>
           <a:lstStyle>
             <a:lvl1pPr algn="l">
-              <a:defRPr sz="3000" b="1" cap="all"/>
+              <a:defRPr sz="4000" b="1" cap="all"/>
             </a:lvl1pPr>
           </a:lstStyle>
           <a:p>
             <a:r>
-              <a:rPr lang="en-US"/>
+              <a:rPr lang="en-US" smtClean="0"/>
               <a:t>Click to edit Master title style</a:t>
             </a:r>
+            <a:endParaRPr lang="en-US"/>
           </a:p>
         </p:txBody>
       </p:sp>
@@ -1499,8 +933,8 @@
         </p:nvSpPr>
         <p:spPr>
           <a:xfrm>
-            <a:off x="722313" y="2180035"/>
-            <a:ext cx="7772400" cy="1125140"/>
+            <a:off x="722313" y="2906713"/>
+            <a:ext cx="7772400" cy="1500187"/>
           </a:xfrm>
         </p:spPr>
         <p:txBody>
@@ -1508,7 +942,7 @@
           <a:lstStyle>
             <a:lvl1pPr marL="0" indent="0">
               <a:buNone/>
-              <a:defRPr sz="1500">
+              <a:defRPr sz="2000">
                 <a:solidFill>
                   <a:schemeClr val="tx1">
                     <a:tint val="75000"/>
@@ -1516,9 +950,9 @@
                 </a:solidFill>
               </a:defRPr>
             </a:lvl1pPr>
-            <a:lvl2pPr marL="342900" indent="0">
-              <a:buNone/>
-              <a:defRPr sz="1350">
+            <a:lvl2pPr marL="457200" indent="0">
+              <a:buNone/>
+              <a:defRPr sz="1800">
                 <a:solidFill>
                   <a:schemeClr val="tx1">
                     <a:tint val="75000"/>
@@ -1526,9 +960,9 @@
                 </a:solidFill>
               </a:defRPr>
             </a:lvl2pPr>
-            <a:lvl3pPr marL="685800" indent="0">
-              <a:buNone/>
-              <a:defRPr sz="1200">
+            <a:lvl3pPr marL="914400" indent="0">
+              <a:buNone/>
+              <a:defRPr sz="1600">
                 <a:solidFill>
                   <a:schemeClr val="tx1">
                     <a:tint val="75000"/>
@@ -1536,9 +970,9 @@
                 </a:solidFill>
               </a:defRPr>
             </a:lvl3pPr>
-            <a:lvl4pPr marL="1028700" indent="0">
-              <a:buNone/>
-              <a:defRPr sz="1050">
+            <a:lvl4pPr marL="1371600" indent="0">
+              <a:buNone/>
+              <a:defRPr sz="1400">
                 <a:solidFill>
                   <a:schemeClr val="tx1">
                     <a:tint val="75000"/>
@@ -1546,9 +980,9 @@
                 </a:solidFill>
               </a:defRPr>
             </a:lvl4pPr>
-            <a:lvl5pPr marL="1371600" indent="0">
-              <a:buNone/>
-              <a:defRPr sz="1050">
+            <a:lvl5pPr marL="1828800" indent="0">
+              <a:buNone/>
+              <a:defRPr sz="1400">
                 <a:solidFill>
                   <a:schemeClr val="tx1">
                     <a:tint val="75000"/>
@@ -1556,9 +990,9 @@
                 </a:solidFill>
               </a:defRPr>
             </a:lvl5pPr>
-            <a:lvl6pPr marL="1714500" indent="0">
-              <a:buNone/>
-              <a:defRPr sz="1050">
+            <a:lvl6pPr marL="2286000" indent="0">
+              <a:buNone/>
+              <a:defRPr sz="1400">
                 <a:solidFill>
                   <a:schemeClr val="tx1">
                     <a:tint val="75000"/>
@@ -1566,9 +1000,9 @@
                 </a:solidFill>
               </a:defRPr>
             </a:lvl6pPr>
-            <a:lvl7pPr marL="2057400" indent="0">
-              <a:buNone/>
-              <a:defRPr sz="1050">
+            <a:lvl7pPr marL="2743200" indent="0">
+              <a:buNone/>
+              <a:defRPr sz="1400">
                 <a:solidFill>
                   <a:schemeClr val="tx1">
                     <a:tint val="75000"/>
@@ -1576,9 +1010,9 @@
                 </a:solidFill>
               </a:defRPr>
             </a:lvl7pPr>
-            <a:lvl8pPr marL="2400300" indent="0">
-              <a:buNone/>
-              <a:defRPr sz="1050">
+            <a:lvl8pPr marL="3200400" indent="0">
+              <a:buNone/>
+              <a:defRPr sz="1400">
                 <a:solidFill>
                   <a:schemeClr val="tx1">
                     <a:tint val="75000"/>
@@ -1586,9 +1020,9 @@
                 </a:solidFill>
               </a:defRPr>
             </a:lvl8pPr>
-            <a:lvl9pPr marL="2743200" indent="0">
-              <a:buNone/>
-              <a:defRPr sz="1050">
+            <a:lvl9pPr marL="3657600" indent="0">
+              <a:buNone/>
+              <a:defRPr sz="1400">
                 <a:solidFill>
                   <a:schemeClr val="tx1">
                     <a:tint val="75000"/>
@@ -1600,7 +1034,7 @@
           <a:p>
             <a:pPr lvl="0"/>
             <a:r>
-              <a:rPr lang="en-US"/>
+              <a:rPr lang="en-US" smtClean="0"/>
               <a:t>Click to edit Master text styles</a:t>
             </a:r>
           </a:p>
@@ -1621,9 +1055,9 @@
           <a:bodyPr/>
           <a:lstStyle/>
           <a:p>
-            <a:fld id="{241EB5C9-1307-BA42-ABA2-0BC069CD8E7F}" type="datetimeFigureOut">
-              <a:rPr lang="en-US" smtClean="0"/>
-              <a:t>1/2/22</a:t>
+            <a:fld id="{5BCAD085-E8A6-8845-BD4E-CB4CCA059FC4}" type="datetimeFigureOut">
+              <a:rPr lang="en-US" smtClean="0"/>
+              <a:t>1/27/13</a:t>
             </a:fld>
             <a:endParaRPr lang="en-US"/>
           </a:p>
@@ -1663,7 +1097,7 @@
           <a:bodyPr/>
           <a:lstStyle/>
           <a:p>
-            <a:fld id="{C5EF2332-01BF-834F-8236-50238282D533}" type="slidenum">
+            <a:fld id="{C1FF6DA9-008F-8B48-92A6-B652298478BF}" type="slidenum">
               <a:rPr lang="en-US" smtClean="0"/>
               <a:t>‹#›</a:t>
             </a:fld>
@@ -1674,7 +1108,7 @@
     </p:spTree>
     <p:extLst>
       <p:ext uri="{BB962C8B-B14F-4D97-AF65-F5344CB8AC3E}">
-        <p14:creationId xmlns:p14="http://schemas.microsoft.com/office/powerpoint/2010/main" val="1073069076"/>
+        <p14:creationId xmlns:p14="http://schemas.microsoft.com/office/powerpoint/2010/main" val="960648375"/>
       </p:ext>
     </p:extLst>
   </p:cSld>
@@ -1717,9 +1151,10 @@
           <a:lstStyle/>
           <a:p>
             <a:r>
-              <a:rPr lang="en-US"/>
+              <a:rPr lang="en-US" smtClean="0"/>
               <a:t>Click to edit Master title style</a:t>
             </a:r>
+            <a:endParaRPr lang="en-US"/>
           </a:p>
         </p:txBody>
       </p:sp>
@@ -1735,75 +1170,76 @@
         </p:nvSpPr>
         <p:spPr>
           <a:xfrm>
-            <a:off x="457200" y="1200151"/>
-            <a:ext cx="4038600" cy="3394472"/>
+            <a:off x="457200" y="1600200"/>
+            <a:ext cx="4038600" cy="4525963"/>
           </a:xfrm>
         </p:spPr>
         <p:txBody>
           <a:bodyPr/>
           <a:lstStyle>
             <a:lvl1pPr>
-              <a:defRPr sz="2100"/>
+              <a:defRPr sz="2800"/>
             </a:lvl1pPr>
             <a:lvl2pPr>
-              <a:defRPr sz="1800"/>
+              <a:defRPr sz="2400"/>
             </a:lvl2pPr>
             <a:lvl3pPr>
-              <a:defRPr sz="1500"/>
+              <a:defRPr sz="2000"/>
             </a:lvl3pPr>
             <a:lvl4pPr>
-              <a:defRPr sz="1350"/>
+              <a:defRPr sz="1800"/>
             </a:lvl4pPr>
             <a:lvl5pPr>
-              <a:defRPr sz="1350"/>
+              <a:defRPr sz="1800"/>
             </a:lvl5pPr>
             <a:lvl6pPr>
-              <a:defRPr sz="1350"/>
+              <a:defRPr sz="1800"/>
             </a:lvl6pPr>
             <a:lvl7pPr>
-              <a:defRPr sz="1350"/>
+              <a:defRPr sz="1800"/>
             </a:lvl7pPr>
             <a:lvl8pPr>
-              <a:defRPr sz="1350"/>
+              <a:defRPr sz="1800"/>
             </a:lvl8pPr>
             <a:lvl9pPr>
-              <a:defRPr sz="1350"/>
+              <a:defRPr sz="1800"/>
             </a:lvl9pPr>
           </a:lstStyle>
           <a:p>
             <a:pPr lvl="0"/>
             <a:r>
-              <a:rPr lang="en-US"/>
+              <a:rPr lang="en-US" smtClean="0"/>
               <a:t>Click to edit Master text styles</a:t>
             </a:r>
           </a:p>
           <a:p>
             <a:pPr lvl="1"/>
             <a:r>
-              <a:rPr lang="en-US"/>
+              <a:rPr lang="en-US" smtClean="0"/>
               <a:t>Second level</a:t>
             </a:r>
           </a:p>
           <a:p>
             <a:pPr lvl="2"/>
             <a:r>
-              <a:rPr lang="en-US"/>
+              <a:rPr lang="en-US" smtClean="0"/>
               <a:t>Third level</a:t>
             </a:r>
           </a:p>
           <a:p>
             <a:pPr lvl="3"/>
             <a:r>
-              <a:rPr lang="en-US"/>
+              <a:rPr lang="en-US" smtClean="0"/>
               <a:t>Fourth level</a:t>
             </a:r>
           </a:p>
           <a:p>
             <a:pPr lvl="4"/>
             <a:r>
-              <a:rPr lang="en-US"/>
+              <a:rPr lang="en-US" smtClean="0"/>
               <a:t>Fifth level</a:t>
             </a:r>
+            <a:endParaRPr lang="en-US"/>
           </a:p>
         </p:txBody>
       </p:sp>
@@ -1819,75 +1255,76 @@
         </p:nvSpPr>
         <p:spPr>
           <a:xfrm>
-            <a:off x="4648200" y="1200151"/>
-            <a:ext cx="4038600" cy="3394472"/>
+            <a:off x="4648200" y="1600200"/>
+            <a:ext cx="4038600" cy="4525963"/>
           </a:xfrm>
         </p:spPr>
         <p:txBody>
           <a:bodyPr/>
           <a:lstStyle>
             <a:lvl1pPr>
-              <a:defRPr sz="2100"/>
+              <a:defRPr sz="2800"/>
             </a:lvl1pPr>
             <a:lvl2pPr>
-              <a:defRPr sz="1800"/>
+              <a:defRPr sz="2400"/>
             </a:lvl2pPr>
             <a:lvl3pPr>
-              <a:defRPr sz="1500"/>
+              <a:defRPr sz="2000"/>
             </a:lvl3pPr>
             <a:lvl4pPr>
-              <a:defRPr sz="1350"/>
+              <a:defRPr sz="1800"/>
             </a:lvl4pPr>
             <a:lvl5pPr>
-              <a:defRPr sz="1350"/>
+              <a:defRPr sz="1800"/>
             </a:lvl5pPr>
             <a:lvl6pPr>
-              <a:defRPr sz="1350"/>
+              <a:defRPr sz="1800"/>
             </a:lvl6pPr>
             <a:lvl7pPr>
-              <a:defRPr sz="1350"/>
+              <a:defRPr sz="1800"/>
             </a:lvl7pPr>
             <a:lvl8pPr>
-              <a:defRPr sz="1350"/>
+              <a:defRPr sz="1800"/>
             </a:lvl8pPr>
             <a:lvl9pPr>
-              <a:defRPr sz="1350"/>
+              <a:defRPr sz="1800"/>
             </a:lvl9pPr>
           </a:lstStyle>
           <a:p>
             <a:pPr lvl="0"/>
             <a:r>
-              <a:rPr lang="en-US"/>
+              <a:rPr lang="en-US" smtClean="0"/>
               <a:t>Click to edit Master text styles</a:t>
             </a:r>
           </a:p>
           <a:p>
             <a:pPr lvl="1"/>
             <a:r>
-              <a:rPr lang="en-US"/>
+              <a:rPr lang="en-US" smtClean="0"/>
               <a:t>Second level</a:t>
             </a:r>
           </a:p>
           <a:p>
             <a:pPr lvl="2"/>
             <a:r>
-              <a:rPr lang="en-US"/>
+              <a:rPr lang="en-US" smtClean="0"/>
               <a:t>Third level</a:t>
             </a:r>
           </a:p>
           <a:p>
             <a:pPr lvl="3"/>
             <a:r>
-              <a:rPr lang="en-US"/>
+              <a:rPr lang="en-US" smtClean="0"/>
               <a:t>Fourth level</a:t>
             </a:r>
           </a:p>
           <a:p>
             <a:pPr lvl="4"/>
             <a:r>
-              <a:rPr lang="en-US"/>
+              <a:rPr lang="en-US" smtClean="0"/>
               <a:t>Fifth level</a:t>
             </a:r>
+            <a:endParaRPr lang="en-US"/>
           </a:p>
         </p:txBody>
       </p:sp>
@@ -1906,9 +1343,9 @@
           <a:bodyPr/>
           <a:lstStyle/>
           <a:p>
-            <a:fld id="{241EB5C9-1307-BA42-ABA2-0BC069CD8E7F}" type="datetimeFigureOut">
-              <a:rPr lang="en-US" smtClean="0"/>
-              <a:t>1/2/22</a:t>
+            <a:fld id="{5BCAD085-E8A6-8845-BD4E-CB4CCA059FC4}" type="datetimeFigureOut">
+              <a:rPr lang="en-US" smtClean="0"/>
+              <a:t>1/27/13</a:t>
             </a:fld>
             <a:endParaRPr lang="en-US"/>
           </a:p>
@@ -1948,7 +1385,7 @@
           <a:bodyPr/>
           <a:lstStyle/>
           <a:p>
-            <a:fld id="{C5EF2332-01BF-834F-8236-50238282D533}" type="slidenum">
+            <a:fld id="{C1FF6DA9-008F-8B48-92A6-B652298478BF}" type="slidenum">
               <a:rPr lang="en-US" smtClean="0"/>
               <a:t>‹#›</a:t>
             </a:fld>
@@ -1959,7 +1396,7 @@
     </p:spTree>
     <p:extLst>
       <p:ext uri="{BB962C8B-B14F-4D97-AF65-F5344CB8AC3E}">
-        <p14:creationId xmlns:p14="http://schemas.microsoft.com/office/powerpoint/2010/main" val="2619886245"/>
+        <p14:creationId xmlns:p14="http://schemas.microsoft.com/office/powerpoint/2010/main" val="2782244947"/>
       </p:ext>
     </p:extLst>
   </p:cSld>
@@ -2006,9 +1443,10 @@
           </a:lstStyle>
           <a:p>
             <a:r>
-              <a:rPr lang="en-US"/>
+              <a:rPr lang="en-US" smtClean="0"/>
               <a:t>Click to edit Master title style</a:t>
             </a:r>
+            <a:endParaRPr lang="en-US"/>
           </a:p>
         </p:txBody>
       </p:sp>
@@ -2024,8 +1462,8 @@
         </p:nvSpPr>
         <p:spPr>
           <a:xfrm>
-            <a:off x="457200" y="1151335"/>
-            <a:ext cx="4040188" cy="479822"/>
+            <a:off x="457200" y="1535113"/>
+            <a:ext cx="4040188" cy="639762"/>
           </a:xfrm>
         </p:spPr>
         <p:txBody>
@@ -2033,45 +1471,45 @@
           <a:lstStyle>
             <a:lvl1pPr marL="0" indent="0">
               <a:buNone/>
+              <a:defRPr sz="2400" b="1"/>
+            </a:lvl1pPr>
+            <a:lvl2pPr marL="457200" indent="0">
+              <a:buNone/>
+              <a:defRPr sz="2000" b="1"/>
+            </a:lvl2pPr>
+            <a:lvl3pPr marL="914400" indent="0">
+              <a:buNone/>
               <a:defRPr sz="1800" b="1"/>
-            </a:lvl1pPr>
-            <a:lvl2pPr marL="342900" indent="0">
-              <a:buNone/>
-              <a:defRPr sz="1500" b="1"/>
-            </a:lvl2pPr>
-            <a:lvl3pPr marL="685800" indent="0">
-              <a:buNone/>
-              <a:defRPr sz="1350" b="1"/>
             </a:lvl3pPr>
-            <a:lvl4pPr marL="1028700" indent="0">
-              <a:buNone/>
-              <a:defRPr sz="1200" b="1"/>
+            <a:lvl4pPr marL="1371600" indent="0">
+              <a:buNone/>
+              <a:defRPr sz="1600" b="1"/>
             </a:lvl4pPr>
-            <a:lvl5pPr marL="1371600" indent="0">
-              <a:buNone/>
-              <a:defRPr sz="1200" b="1"/>
+            <a:lvl5pPr marL="1828800" indent="0">
+              <a:buNone/>
+              <a:defRPr sz="1600" b="1"/>
             </a:lvl5pPr>
-            <a:lvl6pPr marL="1714500" indent="0">
-              <a:buNone/>
-              <a:defRPr sz="1200" b="1"/>
+            <a:lvl6pPr marL="2286000" indent="0">
+              <a:buNone/>
+              <a:defRPr sz="1600" b="1"/>
             </a:lvl6pPr>
-            <a:lvl7pPr marL="2057400" indent="0">
-              <a:buNone/>
-              <a:defRPr sz="1200" b="1"/>
+            <a:lvl7pPr marL="2743200" indent="0">
+              <a:buNone/>
+              <a:defRPr sz="1600" b="1"/>
             </a:lvl7pPr>
-            <a:lvl8pPr marL="2400300" indent="0">
-              <a:buNone/>
-              <a:defRPr sz="1200" b="1"/>
+            <a:lvl8pPr marL="3200400" indent="0">
+              <a:buNone/>
+              <a:defRPr sz="1600" b="1"/>
             </a:lvl8pPr>
-            <a:lvl9pPr marL="2743200" indent="0">
-              <a:buNone/>
-              <a:defRPr sz="1200" b="1"/>
+            <a:lvl9pPr marL="3657600" indent="0">
+              <a:buNone/>
+              <a:defRPr sz="1600" b="1"/>
             </a:lvl9pPr>
           </a:lstStyle>
           <a:p>
             <a:pPr lvl="0"/>
             <a:r>
-              <a:rPr lang="en-US"/>
+              <a:rPr lang="en-US" smtClean="0"/>
               <a:t>Click to edit Master text styles</a:t>
             </a:r>
           </a:p>
@@ -2089,75 +1527,76 @@
         </p:nvSpPr>
         <p:spPr>
           <a:xfrm>
-            <a:off x="457200" y="1631156"/>
-            <a:ext cx="4040188" cy="2963466"/>
+            <a:off x="457200" y="2174875"/>
+            <a:ext cx="4040188" cy="3951288"/>
           </a:xfrm>
         </p:spPr>
         <p:txBody>
           <a:bodyPr/>
           <a:lstStyle>
             <a:lvl1pPr>
-              <a:defRPr sz="1800"/>
+              <a:defRPr sz="2400"/>
             </a:lvl1pPr>
             <a:lvl2pPr>
-              <a:defRPr sz="1500"/>
+              <a:defRPr sz="2000"/>
             </a:lvl2pPr>
             <a:lvl3pPr>
-              <a:defRPr sz="1350"/>
+              <a:defRPr sz="1800"/>
             </a:lvl3pPr>
             <a:lvl4pPr>
-              <a:defRPr sz="1200"/>
+              <a:defRPr sz="1600"/>
             </a:lvl4pPr>
             <a:lvl5pPr>
-              <a:defRPr sz="1200"/>
+              <a:defRPr sz="1600"/>
             </a:lvl5pPr>
             <a:lvl6pPr>
-              <a:defRPr sz="1200"/>
+              <a:defRPr sz="1600"/>
             </a:lvl6pPr>
             <a:lvl7pPr>
-              <a:defRPr sz="1200"/>
+              <a:defRPr sz="1600"/>
             </a:lvl7pPr>
             <a:lvl8pPr>
-              <a:defRPr sz="1200"/>
+              <a:defRPr sz="1600"/>
             </a:lvl8pPr>
             <a:lvl9pPr>
-              <a:defRPr sz="1200"/>
+              <a:defRPr sz="1600"/>
             </a:lvl9pPr>
           </a:lstStyle>
           <a:p>
             <a:pPr lvl="0"/>
             <a:r>
-              <a:rPr lang="en-US"/>
+              <a:rPr lang="en-US" smtClean="0"/>
               <a:t>Click to edit Master text styles</a:t>
             </a:r>
           </a:p>
           <a:p>
             <a:pPr lvl="1"/>
             <a:r>
-              <a:rPr lang="en-US"/>
+              <a:rPr lang="en-US" smtClean="0"/>
               <a:t>Second level</a:t>
             </a:r>
           </a:p>
           <a:p>
             <a:pPr lvl="2"/>
             <a:r>
-              <a:rPr lang="en-US"/>
+              <a:rPr lang="en-US" smtClean="0"/>
               <a:t>Third level</a:t>
             </a:r>
           </a:p>
           <a:p>
             <a:pPr lvl="3"/>
             <a:r>
-              <a:rPr lang="en-US"/>
+              <a:rPr lang="en-US" smtClean="0"/>
               <a:t>Fourth level</a:t>
             </a:r>
           </a:p>
           <a:p>
             <a:pPr lvl="4"/>
             <a:r>
-              <a:rPr lang="en-US"/>
+              <a:rPr lang="en-US" smtClean="0"/>
               <a:t>Fifth level</a:t>
             </a:r>
+            <a:endParaRPr lang="en-US"/>
           </a:p>
         </p:txBody>
       </p:sp>
@@ -2173,8 +1612,8 @@
         </p:nvSpPr>
         <p:spPr>
           <a:xfrm>
-            <a:off x="4645026" y="1151335"/>
-            <a:ext cx="4041775" cy="479822"/>
+            <a:off x="4645025" y="1535113"/>
+            <a:ext cx="4041775" cy="639762"/>
           </a:xfrm>
         </p:spPr>
         <p:txBody>
@@ -2182,45 +1621,45 @@
           <a:lstStyle>
             <a:lvl1pPr marL="0" indent="0">
               <a:buNone/>
+              <a:defRPr sz="2400" b="1"/>
+            </a:lvl1pPr>
+            <a:lvl2pPr marL="457200" indent="0">
+              <a:buNone/>
+              <a:defRPr sz="2000" b="1"/>
+            </a:lvl2pPr>
+            <a:lvl3pPr marL="914400" indent="0">
+              <a:buNone/>
               <a:defRPr sz="1800" b="1"/>
-            </a:lvl1pPr>
-            <a:lvl2pPr marL="342900" indent="0">
-              <a:buNone/>
-              <a:defRPr sz="1500" b="1"/>
-            </a:lvl2pPr>
-            <a:lvl3pPr marL="685800" indent="0">
-              <a:buNone/>
-              <a:defRPr sz="1350" b="1"/>
             </a:lvl3pPr>
-            <a:lvl4pPr marL="1028700" indent="0">
-              <a:buNone/>
-              <a:defRPr sz="1200" b="1"/>
+            <a:lvl4pPr marL="1371600" indent="0">
+              <a:buNone/>
+              <a:defRPr sz="1600" b="1"/>
             </a:lvl4pPr>
-            <a:lvl5pPr marL="1371600" indent="0">
-              <a:buNone/>
-              <a:defRPr sz="1200" b="1"/>
+            <a:lvl5pPr marL="1828800" indent="0">
+              <a:buNone/>
+              <a:defRPr sz="1600" b="1"/>
             </a:lvl5pPr>
-            <a:lvl6pPr marL="1714500" indent="0">
-              <a:buNone/>
-              <a:defRPr sz="1200" b="1"/>
+            <a:lvl6pPr marL="2286000" indent="0">
+              <a:buNone/>
+              <a:defRPr sz="1600" b="1"/>
             </a:lvl6pPr>
-            <a:lvl7pPr marL="2057400" indent="0">
-              <a:buNone/>
-              <a:defRPr sz="1200" b="1"/>
+            <a:lvl7pPr marL="2743200" indent="0">
+              <a:buNone/>
+              <a:defRPr sz="1600" b="1"/>
             </a:lvl7pPr>
-            <a:lvl8pPr marL="2400300" indent="0">
-              <a:buNone/>
-              <a:defRPr sz="1200" b="1"/>
+            <a:lvl8pPr marL="3200400" indent="0">
+              <a:buNone/>
+              <a:defRPr sz="1600" b="1"/>
             </a:lvl8pPr>
-            <a:lvl9pPr marL="2743200" indent="0">
-              <a:buNone/>
-              <a:defRPr sz="1200" b="1"/>
+            <a:lvl9pPr marL="3657600" indent="0">
+              <a:buNone/>
+              <a:defRPr sz="1600" b="1"/>
             </a:lvl9pPr>
           </a:lstStyle>
           <a:p>
             <a:pPr lvl="0"/>
             <a:r>
-              <a:rPr lang="en-US"/>
+              <a:rPr lang="en-US" smtClean="0"/>
               <a:t>Click to edit Master text styles</a:t>
             </a:r>
           </a:p>
@@ -2238,75 +1677,76 @@
         </p:nvSpPr>
         <p:spPr>
           <a:xfrm>
-            <a:off x="4645026" y="1631156"/>
-            <a:ext cx="4041775" cy="2963466"/>
+            <a:off x="4645025" y="2174875"/>
+            <a:ext cx="4041775" cy="3951288"/>
           </a:xfrm>
         </p:spPr>
         <p:txBody>
           <a:bodyPr/>
           <a:lstStyle>
             <a:lvl1pPr>
-              <a:defRPr sz="1800"/>
+              <a:defRPr sz="2400"/>
             </a:lvl1pPr>
             <a:lvl2pPr>
-              <a:defRPr sz="1500"/>
+              <a:defRPr sz="2000"/>
             </a:lvl2pPr>
             <a:lvl3pPr>
-              <a:defRPr sz="1350"/>
+              <a:defRPr sz="1800"/>
             </a:lvl3pPr>
             <a:lvl4pPr>
-              <a:defRPr sz="1200"/>
+              <a:defRPr sz="1600"/>
             </a:lvl4pPr>
             <a:lvl5pPr>
-              <a:defRPr sz="1200"/>
+              <a:defRPr sz="1600"/>
             </a:lvl5pPr>
             <a:lvl6pPr>
-              <a:defRPr sz="1200"/>
+              <a:defRPr sz="1600"/>
             </a:lvl6pPr>
             <a:lvl7pPr>
-              <a:defRPr sz="1200"/>
+              <a:defRPr sz="1600"/>
             </a:lvl7pPr>
             <a:lvl8pPr>
-              <a:defRPr sz="1200"/>
+              <a:defRPr sz="1600"/>
             </a:lvl8pPr>
             <a:lvl9pPr>
-              <a:defRPr sz="1200"/>
+              <a:defRPr sz="1600"/>
             </a:lvl9pPr>
           </a:lstStyle>
           <a:p>
             <a:pPr lvl="0"/>
             <a:r>
-              <a:rPr lang="en-US"/>
+              <a:rPr lang="en-US" smtClean="0"/>
               <a:t>Click to edit Master text styles</a:t>
             </a:r>
           </a:p>
           <a:p>
             <a:pPr lvl="1"/>
             <a:r>
-              <a:rPr lang="en-US"/>
+              <a:rPr lang="en-US" smtClean="0"/>
               <a:t>Second level</a:t>
             </a:r>
           </a:p>
           <a:p>
             <a:pPr lvl="2"/>
             <a:r>
-              <a:rPr lang="en-US"/>
+              <a:rPr lang="en-US" smtClean="0"/>
               <a:t>Third level</a:t>
             </a:r>
           </a:p>
           <a:p>
             <a:pPr lvl="3"/>
             <a:r>
-              <a:rPr lang="en-US"/>
+              <a:rPr lang="en-US" smtClean="0"/>
               <a:t>Fourth level</a:t>
             </a:r>
           </a:p>
           <a:p>
             <a:pPr lvl="4"/>
             <a:r>
-              <a:rPr lang="en-US"/>
+              <a:rPr lang="en-US" smtClean="0"/>
               <a:t>Fifth level</a:t>
             </a:r>
+            <a:endParaRPr lang="en-US"/>
           </a:p>
         </p:txBody>
       </p:sp>
@@ -2325,9 +1765,9 @@
           <a:bodyPr/>
           <a:lstStyle/>
           <a:p>
-            <a:fld id="{241EB5C9-1307-BA42-ABA2-0BC069CD8E7F}" type="datetimeFigureOut">
-              <a:rPr lang="en-US" smtClean="0"/>
-              <a:t>1/2/22</a:t>
+            <a:fld id="{5BCAD085-E8A6-8845-BD4E-CB4CCA059FC4}" type="datetimeFigureOut">
+              <a:rPr lang="en-US" smtClean="0"/>
+              <a:t>1/27/13</a:t>
             </a:fld>
             <a:endParaRPr lang="en-US"/>
           </a:p>
@@ -2367,7 +1807,7 @@
           <a:bodyPr/>
           <a:lstStyle/>
           <a:p>
-            <a:fld id="{C5EF2332-01BF-834F-8236-50238282D533}" type="slidenum">
+            <a:fld id="{C1FF6DA9-008F-8B48-92A6-B652298478BF}" type="slidenum">
               <a:rPr lang="en-US" smtClean="0"/>
               <a:t>‹#›</a:t>
             </a:fld>
@@ -2378,7 +1818,7 @@
     </p:spTree>
     <p:extLst>
       <p:ext uri="{BB962C8B-B14F-4D97-AF65-F5344CB8AC3E}">
-        <p14:creationId xmlns:p14="http://schemas.microsoft.com/office/powerpoint/2010/main" val="2535793967"/>
+        <p14:creationId xmlns:p14="http://schemas.microsoft.com/office/powerpoint/2010/main" val="990158736"/>
       </p:ext>
     </p:extLst>
   </p:cSld>
@@ -2421,9 +1861,10 @@
           <a:lstStyle/>
           <a:p>
             <a:r>
-              <a:rPr lang="en-US"/>
+              <a:rPr lang="en-US" smtClean="0"/>
               <a:t>Click to edit Master title style</a:t>
             </a:r>
+            <a:endParaRPr lang="en-US"/>
           </a:p>
         </p:txBody>
       </p:sp>
@@ -2442,9 +1883,9 @@
           <a:bodyPr/>
           <a:lstStyle/>
           <a:p>
-            <a:fld id="{241EB5C9-1307-BA42-ABA2-0BC069CD8E7F}" type="datetimeFigureOut">
-              <a:rPr lang="en-US" smtClean="0"/>
-              <a:t>1/2/22</a:t>
+            <a:fld id="{5BCAD085-E8A6-8845-BD4E-CB4CCA059FC4}" type="datetimeFigureOut">
+              <a:rPr lang="en-US" smtClean="0"/>
+              <a:t>1/27/13</a:t>
             </a:fld>
             <a:endParaRPr lang="en-US"/>
           </a:p>
@@ -2484,7 +1925,7 @@
           <a:bodyPr/>
           <a:lstStyle/>
           <a:p>
-            <a:fld id="{C5EF2332-01BF-834F-8236-50238282D533}" type="slidenum">
+            <a:fld id="{C1FF6DA9-008F-8B48-92A6-B652298478BF}" type="slidenum">
               <a:rPr lang="en-US" smtClean="0"/>
               <a:t>‹#›</a:t>
             </a:fld>
@@ -2495,7 +1936,7 @@
     </p:spTree>
     <p:extLst>
       <p:ext uri="{BB962C8B-B14F-4D97-AF65-F5344CB8AC3E}">
-        <p14:creationId xmlns:p14="http://schemas.microsoft.com/office/powerpoint/2010/main" val="3472721253"/>
+        <p14:creationId xmlns:p14="http://schemas.microsoft.com/office/powerpoint/2010/main" val="727027711"/>
       </p:ext>
     </p:extLst>
   </p:cSld>
@@ -2537,9 +1978,9 @@
           <a:bodyPr/>
           <a:lstStyle/>
           <a:p>
-            <a:fld id="{241EB5C9-1307-BA42-ABA2-0BC069CD8E7F}" type="datetimeFigureOut">
-              <a:rPr lang="en-US" smtClean="0"/>
-              <a:t>1/2/22</a:t>
+            <a:fld id="{5BCAD085-E8A6-8845-BD4E-CB4CCA059FC4}" type="datetimeFigureOut">
+              <a:rPr lang="en-US" smtClean="0"/>
+              <a:t>1/27/13</a:t>
             </a:fld>
             <a:endParaRPr lang="en-US"/>
           </a:p>
@@ -2579,7 +2020,7 @@
           <a:bodyPr/>
           <a:lstStyle/>
           <a:p>
-            <a:fld id="{C5EF2332-01BF-834F-8236-50238282D533}" type="slidenum">
+            <a:fld id="{C1FF6DA9-008F-8B48-92A6-B652298478BF}" type="slidenum">
               <a:rPr lang="en-US" smtClean="0"/>
               <a:t>‹#›</a:t>
             </a:fld>
@@ -2590,7 +2031,7 @@
     </p:spTree>
     <p:extLst>
       <p:ext uri="{BB962C8B-B14F-4D97-AF65-F5344CB8AC3E}">
-        <p14:creationId xmlns:p14="http://schemas.microsoft.com/office/powerpoint/2010/main" val="2130901097"/>
+        <p14:creationId xmlns:p14="http://schemas.microsoft.com/office/powerpoint/2010/main" val="1212999818"/>
       </p:ext>
     </p:extLst>
   </p:cSld>
@@ -2629,22 +2070,23 @@
         </p:nvSpPr>
         <p:spPr>
           <a:xfrm>
-            <a:off x="457201" y="204787"/>
-            <a:ext cx="3008313" cy="871538"/>
+            <a:off x="457200" y="273050"/>
+            <a:ext cx="3008313" cy="1162050"/>
           </a:xfrm>
         </p:spPr>
         <p:txBody>
           <a:bodyPr anchor="b"/>
           <a:lstStyle>
             <a:lvl1pPr algn="l">
-              <a:defRPr sz="1500" b="1"/>
+              <a:defRPr sz="2000" b="1"/>
             </a:lvl1pPr>
           </a:lstStyle>
           <a:p>
             <a:r>
-              <a:rPr lang="en-US"/>
+              <a:rPr lang="en-US" smtClean="0"/>
               <a:t>Click to edit Master title style</a:t>
             </a:r>
+            <a:endParaRPr lang="en-US"/>
           </a:p>
         </p:txBody>
       </p:sp>
@@ -2660,75 +2102,76 @@
         </p:nvSpPr>
         <p:spPr>
           <a:xfrm>
-            <a:off x="3575050" y="204788"/>
-            <a:ext cx="5111750" cy="4389835"/>
+            <a:off x="3575050" y="273050"/>
+            <a:ext cx="5111750" cy="5853113"/>
           </a:xfrm>
         </p:spPr>
         <p:txBody>
           <a:bodyPr/>
           <a:lstStyle>
             <a:lvl1pPr>
-              <a:defRPr sz="2400"/>
+              <a:defRPr sz="3200"/>
             </a:lvl1pPr>
             <a:lvl2pPr>
-              <a:defRPr sz="2100"/>
+              <a:defRPr sz="2800"/>
             </a:lvl2pPr>
             <a:lvl3pPr>
-              <a:defRPr sz="1800"/>
+              <a:defRPr sz="2400"/>
             </a:lvl3pPr>
             <a:lvl4pPr>
-              <a:defRPr sz="1500"/>
+              <a:defRPr sz="2000"/>
             </a:lvl4pPr>
             <a:lvl5pPr>
-              <a:defRPr sz="1500"/>
+              <a:defRPr sz="2000"/>
             </a:lvl5pPr>
             <a:lvl6pPr>
-              <a:defRPr sz="1500"/>
+              <a:defRPr sz="2000"/>
             </a:lvl6pPr>
             <a:lvl7pPr>
-              <a:defRPr sz="1500"/>
+              <a:defRPr sz="2000"/>
             </a:lvl7pPr>
             <a:lvl8pPr>
-              <a:defRPr sz="1500"/>
+              <a:defRPr sz="2000"/>
             </a:lvl8pPr>
             <a:lvl9pPr>
-              <a:defRPr sz="1500"/>
+              <a:defRPr sz="2000"/>
             </a:lvl9pPr>
           </a:lstStyle>
           <a:p>
             <a:pPr lvl="0"/>
             <a:r>
-              <a:rPr lang="en-US"/>
+              <a:rPr lang="en-US" smtClean="0"/>
               <a:t>Click to edit Master text styles</a:t>
             </a:r>
           </a:p>
           <a:p>
             <a:pPr lvl="1"/>
             <a:r>
-              <a:rPr lang="en-US"/>
+              <a:rPr lang="en-US" smtClean="0"/>
               <a:t>Second level</a:t>
             </a:r>
           </a:p>
           <a:p>
             <a:pPr lvl="2"/>
             <a:r>
-              <a:rPr lang="en-US"/>
+              <a:rPr lang="en-US" smtClean="0"/>
               <a:t>Third level</a:t>
             </a:r>
           </a:p>
           <a:p>
             <a:pPr lvl="3"/>
             <a:r>
-              <a:rPr lang="en-US"/>
+              <a:rPr lang="en-US" smtClean="0"/>
               <a:t>Fourth level</a:t>
             </a:r>
           </a:p>
           <a:p>
             <a:pPr lvl="4"/>
             <a:r>
-              <a:rPr lang="en-US"/>
+              <a:rPr lang="en-US" smtClean="0"/>
               <a:t>Fifth level</a:t>
             </a:r>
+            <a:endParaRPr lang="en-US"/>
           </a:p>
         </p:txBody>
       </p:sp>
@@ -2744,8 +2187,8 @@
         </p:nvSpPr>
         <p:spPr>
           <a:xfrm>
-            <a:off x="457201" y="1076326"/>
-            <a:ext cx="3008313" cy="3518297"/>
+            <a:off x="457200" y="1435100"/>
+            <a:ext cx="3008313" cy="4691063"/>
           </a:xfrm>
         </p:spPr>
         <p:txBody>
@@ -2753,45 +2196,45 @@
           <a:lstStyle>
             <a:lvl1pPr marL="0" indent="0">
               <a:buNone/>
-              <a:defRPr sz="1050"/>
+              <a:defRPr sz="1400"/>
             </a:lvl1pPr>
-            <a:lvl2pPr marL="342900" indent="0">
+            <a:lvl2pPr marL="457200" indent="0">
+              <a:buNone/>
+              <a:defRPr sz="1200"/>
+            </a:lvl2pPr>
+            <a:lvl3pPr marL="914400" indent="0">
+              <a:buNone/>
+              <a:defRPr sz="1000"/>
+            </a:lvl3pPr>
+            <a:lvl4pPr marL="1371600" indent="0">
               <a:buNone/>
               <a:defRPr sz="900"/>
-            </a:lvl2pPr>
-            <a:lvl3pPr marL="685800" indent="0">
-              <a:buNone/>
-              <a:defRPr sz="750"/>
-            </a:lvl3pPr>
-            <a:lvl4pPr marL="1028700" indent="0">
-              <a:buNone/>
-              <a:defRPr sz="675"/>
             </a:lvl4pPr>
-            <a:lvl5pPr marL="1371600" indent="0">
-              <a:buNone/>
-              <a:defRPr sz="675"/>
+            <a:lvl5pPr marL="1828800" indent="0">
+              <a:buNone/>
+              <a:defRPr sz="900"/>
             </a:lvl5pPr>
-            <a:lvl6pPr marL="1714500" indent="0">
-              <a:buNone/>
-              <a:defRPr sz="675"/>
+            <a:lvl6pPr marL="2286000" indent="0">
+              <a:buNone/>
+              <a:defRPr sz="900"/>
             </a:lvl6pPr>
-            <a:lvl7pPr marL="2057400" indent="0">
-              <a:buNone/>
-              <a:defRPr sz="675"/>
+            <a:lvl7pPr marL="2743200" indent="0">
+              <a:buNone/>
+              <a:defRPr sz="900"/>
             </a:lvl7pPr>
-            <a:lvl8pPr marL="2400300" indent="0">
-              <a:buNone/>
-              <a:defRPr sz="675"/>
+            <a:lvl8pPr marL="3200400" indent="0">
+              <a:buNone/>
+              <a:defRPr sz="900"/>
             </a:lvl8pPr>
-            <a:lvl9pPr marL="2743200" indent="0">
-              <a:buNone/>
-              <a:defRPr sz="675"/>
+            <a:lvl9pPr marL="3657600" indent="0">
+              <a:buNone/>
+              <a:defRPr sz="900"/>
             </a:lvl9pPr>
           </a:lstStyle>
           <a:p>
             <a:pPr lvl="0"/>
             <a:r>
-              <a:rPr lang="en-US"/>
+              <a:rPr lang="en-US" smtClean="0"/>
               <a:t>Click to edit Master text styles</a:t>
             </a:r>
           </a:p>
@@ -2812,9 +2255,9 @@
           <a:bodyPr/>
           <a:lstStyle/>
           <a:p>
-            <a:fld id="{241EB5C9-1307-BA42-ABA2-0BC069CD8E7F}" type="datetimeFigureOut">
-              <a:rPr lang="en-US" smtClean="0"/>
-              <a:t>1/2/22</a:t>
+            <a:fld id="{5BCAD085-E8A6-8845-BD4E-CB4CCA059FC4}" type="datetimeFigureOut">
+              <a:rPr lang="en-US" smtClean="0"/>
+              <a:t>1/27/13</a:t>
             </a:fld>
             <a:endParaRPr lang="en-US"/>
           </a:p>
@@ -2854,7 +2297,7 @@
           <a:bodyPr/>
           <a:lstStyle/>
           <a:p>
-            <a:fld id="{C5EF2332-01BF-834F-8236-50238282D533}" type="slidenum">
+            <a:fld id="{C1FF6DA9-008F-8B48-92A6-B652298478BF}" type="slidenum">
               <a:rPr lang="en-US" smtClean="0"/>
               <a:t>‹#›</a:t>
             </a:fld>
@@ -2865,7 +2308,7 @@
     </p:spTree>
     <p:extLst>
       <p:ext uri="{BB962C8B-B14F-4D97-AF65-F5344CB8AC3E}">
-        <p14:creationId xmlns:p14="http://schemas.microsoft.com/office/powerpoint/2010/main" val="3540895647"/>
+        <p14:creationId xmlns:p14="http://schemas.microsoft.com/office/powerpoint/2010/main" val="1840726560"/>
       </p:ext>
     </p:extLst>
   </p:cSld>
@@ -2904,22 +2347,23 @@
         </p:nvSpPr>
         <p:spPr>
           <a:xfrm>
-            <a:off x="1792288" y="3600450"/>
-            <a:ext cx="5486400" cy="425054"/>
+            <a:off x="1792288" y="4800600"/>
+            <a:ext cx="5486400" cy="566738"/>
           </a:xfrm>
         </p:spPr>
         <p:txBody>
           <a:bodyPr anchor="b"/>
           <a:lstStyle>
             <a:lvl1pPr algn="l">
-              <a:defRPr sz="1500" b="1"/>
+              <a:defRPr sz="2000" b="1"/>
             </a:lvl1pPr>
           </a:lstStyle>
           <a:p>
             <a:r>
-              <a:rPr lang="en-US"/>
+              <a:rPr lang="en-US" smtClean="0"/>
               <a:t>Click to edit Master title style</a:t>
             </a:r>
+            <a:endParaRPr lang="en-US"/>
           </a:p>
         </p:txBody>
       </p:sp>
@@ -2935,8 +2379,8 @@
         </p:nvSpPr>
         <p:spPr>
           <a:xfrm>
-            <a:off x="1792288" y="459581"/>
-            <a:ext cx="5486400" cy="3086100"/>
+            <a:off x="1792288" y="612775"/>
+            <a:ext cx="5486400" cy="4114800"/>
           </a:xfrm>
         </p:spPr>
         <p:txBody>
@@ -2944,39 +2388,39 @@
           <a:lstStyle>
             <a:lvl1pPr marL="0" indent="0">
               <a:buNone/>
+              <a:defRPr sz="3200"/>
+            </a:lvl1pPr>
+            <a:lvl2pPr marL="457200" indent="0">
+              <a:buNone/>
+              <a:defRPr sz="2800"/>
+            </a:lvl2pPr>
+            <a:lvl3pPr marL="914400" indent="0">
+              <a:buNone/>
               <a:defRPr sz="2400"/>
-            </a:lvl1pPr>
-            <a:lvl2pPr marL="342900" indent="0">
-              <a:buNone/>
-              <a:defRPr sz="2100"/>
-            </a:lvl2pPr>
-            <a:lvl3pPr marL="685800" indent="0">
-              <a:buNone/>
-              <a:defRPr sz="1800"/>
             </a:lvl3pPr>
-            <a:lvl4pPr marL="1028700" indent="0">
-              <a:buNone/>
-              <a:defRPr sz="1500"/>
+            <a:lvl4pPr marL="1371600" indent="0">
+              <a:buNone/>
+              <a:defRPr sz="2000"/>
             </a:lvl4pPr>
-            <a:lvl5pPr marL="1371600" indent="0">
-              <a:buNone/>
-              <a:defRPr sz="1500"/>
+            <a:lvl5pPr marL="1828800" indent="0">
+              <a:buNone/>
+              <a:defRPr sz="2000"/>
             </a:lvl5pPr>
-            <a:lvl6pPr marL="1714500" indent="0">
-              <a:buNone/>
-              <a:defRPr sz="1500"/>
+            <a:lvl6pPr marL="2286000" indent="0">
+              <a:buNone/>
+              <a:defRPr sz="2000"/>
             </a:lvl6pPr>
-            <a:lvl7pPr marL="2057400" indent="0">
-              <a:buNone/>
-              <a:defRPr sz="1500"/>
+            <a:lvl7pPr marL="2743200" indent="0">
+              <a:buNone/>
+              <a:defRPr sz="2000"/>
             </a:lvl7pPr>
-            <a:lvl8pPr marL="2400300" indent="0">
-              <a:buNone/>
-              <a:defRPr sz="1500"/>
+            <a:lvl8pPr marL="3200400" indent="0">
+              <a:buNone/>
+              <a:defRPr sz="2000"/>
             </a:lvl8pPr>
-            <a:lvl9pPr marL="2743200" indent="0">
-              <a:buNone/>
-              <a:defRPr sz="1500"/>
+            <a:lvl9pPr marL="3657600" indent="0">
+              <a:buNone/>
+              <a:defRPr sz="2000"/>
             </a:lvl9pPr>
           </a:lstStyle>
           <a:p>
@@ -2996,8 +2440,8 @@
         </p:nvSpPr>
         <p:spPr>
           <a:xfrm>
-            <a:off x="1792288" y="4025503"/>
-            <a:ext cx="5486400" cy="603647"/>
+            <a:off x="1792288" y="5367338"/>
+            <a:ext cx="5486400" cy="804862"/>
           </a:xfrm>
         </p:spPr>
         <p:txBody>
@@ -3005,45 +2449,45 @@
           <a:lstStyle>
             <a:lvl1pPr marL="0" indent="0">
               <a:buNone/>
-              <a:defRPr sz="1050"/>
+              <a:defRPr sz="1400"/>
             </a:lvl1pPr>
-            <a:lvl2pPr marL="342900" indent="0">
+            <a:lvl2pPr marL="457200" indent="0">
+              <a:buNone/>
+              <a:defRPr sz="1200"/>
+            </a:lvl2pPr>
+            <a:lvl3pPr marL="914400" indent="0">
+              <a:buNone/>
+              <a:defRPr sz="1000"/>
+            </a:lvl3pPr>
+            <a:lvl4pPr marL="1371600" indent="0">
               <a:buNone/>
               <a:defRPr sz="900"/>
-            </a:lvl2pPr>
-            <a:lvl3pPr marL="685800" indent="0">
-              <a:buNone/>
-              <a:defRPr sz="750"/>
-            </a:lvl3pPr>
-            <a:lvl4pPr marL="1028700" indent="0">
-              <a:buNone/>
-              <a:defRPr sz="675"/>
             </a:lvl4pPr>
-            <a:lvl5pPr marL="1371600" indent="0">
-              <a:buNone/>
-              <a:defRPr sz="675"/>
+            <a:lvl5pPr marL="1828800" indent="0">
+              <a:buNone/>
+              <a:defRPr sz="900"/>
             </a:lvl5pPr>
-            <a:lvl6pPr marL="1714500" indent="0">
-              <a:buNone/>
-              <a:defRPr sz="675"/>
+            <a:lvl6pPr marL="2286000" indent="0">
+              <a:buNone/>
+              <a:defRPr sz="900"/>
             </a:lvl6pPr>
-            <a:lvl7pPr marL="2057400" indent="0">
-              <a:buNone/>
-              <a:defRPr sz="675"/>
+            <a:lvl7pPr marL="2743200" indent="0">
+              <a:buNone/>
+              <a:defRPr sz="900"/>
             </a:lvl7pPr>
-            <a:lvl8pPr marL="2400300" indent="0">
-              <a:buNone/>
-              <a:defRPr sz="675"/>
+            <a:lvl8pPr marL="3200400" indent="0">
+              <a:buNone/>
+              <a:defRPr sz="900"/>
             </a:lvl8pPr>
-            <a:lvl9pPr marL="2743200" indent="0">
-              <a:buNone/>
-              <a:defRPr sz="675"/>
+            <a:lvl9pPr marL="3657600" indent="0">
+              <a:buNone/>
+              <a:defRPr sz="900"/>
             </a:lvl9pPr>
           </a:lstStyle>
           <a:p>
             <a:pPr lvl="0"/>
             <a:r>
-              <a:rPr lang="en-US"/>
+              <a:rPr lang="en-US" smtClean="0"/>
               <a:t>Click to edit Master text styles</a:t>
             </a:r>
           </a:p>
@@ -3064,9 +2508,9 @@
           <a:bodyPr/>
           <a:lstStyle/>
           <a:p>
-            <a:fld id="{241EB5C9-1307-BA42-ABA2-0BC069CD8E7F}" type="datetimeFigureOut">
-              <a:rPr lang="en-US" smtClean="0"/>
-              <a:t>1/2/22</a:t>
+            <a:fld id="{5BCAD085-E8A6-8845-BD4E-CB4CCA059FC4}" type="datetimeFigureOut">
+              <a:rPr lang="en-US" smtClean="0"/>
+              <a:t>1/27/13</a:t>
             </a:fld>
             <a:endParaRPr lang="en-US"/>
           </a:p>
@@ -3106,7 +2550,7 @@
           <a:bodyPr/>
           <a:lstStyle/>
           <a:p>
-            <a:fld id="{C5EF2332-01BF-834F-8236-50238282D533}" type="slidenum">
+            <a:fld id="{C1FF6DA9-008F-8B48-92A6-B652298478BF}" type="slidenum">
               <a:rPr lang="en-US" smtClean="0"/>
               <a:t>‹#›</a:t>
             </a:fld>
@@ -3117,7 +2561,7 @@
     </p:spTree>
     <p:extLst>
       <p:ext uri="{BB962C8B-B14F-4D97-AF65-F5344CB8AC3E}">
-        <p14:creationId xmlns:p14="http://schemas.microsoft.com/office/powerpoint/2010/main" val="3566899855"/>
+        <p14:creationId xmlns:p14="http://schemas.microsoft.com/office/powerpoint/2010/main" val="3889236939"/>
       </p:ext>
     </p:extLst>
   </p:cSld>
@@ -3161,8 +2605,8 @@
         </p:nvSpPr>
         <p:spPr>
           <a:xfrm>
-            <a:off x="457200" y="205979"/>
-            <a:ext cx="8229600" cy="857250"/>
+            <a:off x="457200" y="274638"/>
+            <a:ext cx="8229600" cy="1143000"/>
           </a:xfrm>
           <a:prstGeom prst="rect">
             <a:avLst/>
@@ -3175,9 +2619,10 @@
           <a:lstStyle/>
           <a:p>
             <a:r>
-              <a:rPr lang="en-US"/>
+              <a:rPr lang="en-US" smtClean="0"/>
               <a:t>Click to edit Master title style</a:t>
             </a:r>
+            <a:endParaRPr lang="en-US"/>
           </a:p>
         </p:txBody>
       </p:sp>
@@ -3193,8 +2638,8 @@
         </p:nvSpPr>
         <p:spPr>
           <a:xfrm>
-            <a:off x="457200" y="1200151"/>
-            <a:ext cx="8229600" cy="3394472"/>
+            <a:off x="457200" y="1600200"/>
+            <a:ext cx="8229600" cy="4525963"/>
           </a:xfrm>
           <a:prstGeom prst="rect">
             <a:avLst/>
@@ -3208,37 +2653,38 @@
           <a:p>
             <a:pPr lvl="0"/>
             <a:r>
-              <a:rPr lang="en-US"/>
+              <a:rPr lang="en-US" smtClean="0"/>
               <a:t>Click to edit Master text styles</a:t>
             </a:r>
           </a:p>
           <a:p>
             <a:pPr lvl="1"/>
             <a:r>
-              <a:rPr lang="en-US"/>
+              <a:rPr lang="en-US" smtClean="0"/>
               <a:t>Second level</a:t>
             </a:r>
           </a:p>
           <a:p>
             <a:pPr lvl="2"/>
             <a:r>
-              <a:rPr lang="en-US"/>
+              <a:rPr lang="en-US" smtClean="0"/>
               <a:t>Third level</a:t>
             </a:r>
           </a:p>
           <a:p>
             <a:pPr lvl="3"/>
             <a:r>
-              <a:rPr lang="en-US"/>
+              <a:rPr lang="en-US" smtClean="0"/>
               <a:t>Fourth level</a:t>
             </a:r>
           </a:p>
           <a:p>
             <a:pPr lvl="4"/>
             <a:r>
-              <a:rPr lang="en-US"/>
+              <a:rPr lang="en-US" smtClean="0"/>
               <a:t>Fifth level</a:t>
             </a:r>
+            <a:endParaRPr lang="en-US"/>
           </a:p>
         </p:txBody>
       </p:sp>
@@ -3254,8 +2700,8 @@
         </p:nvSpPr>
         <p:spPr>
           <a:xfrm>
-            <a:off x="457200" y="4767263"/>
-            <a:ext cx="2133600" cy="273844"/>
+            <a:off x="457200" y="6356350"/>
+            <a:ext cx="2133600" cy="365125"/>
           </a:xfrm>
           <a:prstGeom prst="rect">
             <a:avLst/>
@@ -3265,7 +2711,7 @@
           <a:bodyPr vert="horz" lIns="91440" tIns="45720" rIns="91440" bIns="45720" rtlCol="0" anchor="ctr"/>
           <a:lstStyle>
             <a:lvl1pPr algn="l">
-              <a:defRPr sz="900">
+              <a:defRPr sz="1200">
                 <a:solidFill>
                   <a:schemeClr val="tx1">
                     <a:tint val="75000"/>
@@ -3275,9 +2721,9 @@
             </a:lvl1pPr>
           </a:lstStyle>
           <a:p>
-            <a:fld id="{241EB5C9-1307-BA42-ABA2-0BC069CD8E7F}" type="datetimeFigureOut">
-              <a:rPr lang="en-US" smtClean="0"/>
-              <a:t>1/2/22</a:t>
+            <a:fld id="{5BCAD085-E8A6-8845-BD4E-CB4CCA059FC4}" type="datetimeFigureOut">
+              <a:rPr lang="en-US" smtClean="0"/>
+              <a:t>1/27/13</a:t>
             </a:fld>
             <a:endParaRPr lang="en-US"/>
           </a:p>
@@ -3295,8 +2741,8 @@
         </p:nvSpPr>
         <p:spPr>
           <a:xfrm>
-            <a:off x="3124200" y="4767263"/>
-            <a:ext cx="2895600" cy="273844"/>
+            <a:off x="3124200" y="6356350"/>
+            <a:ext cx="2895600" cy="365125"/>
           </a:xfrm>
           <a:prstGeom prst="rect">
             <a:avLst/>
@@ -3306,7 +2752,7 @@
           <a:bodyPr vert="horz" lIns="91440" tIns="45720" rIns="91440" bIns="45720" rtlCol="0" anchor="ctr"/>
           <a:lstStyle>
             <a:lvl1pPr algn="ctr">
-              <a:defRPr sz="900">
+              <a:defRPr sz="1200">
                 <a:solidFill>
                   <a:schemeClr val="tx1">
                     <a:tint val="75000"/>
@@ -3332,8 +2778,8 @@
         </p:nvSpPr>
         <p:spPr>
           <a:xfrm>
-            <a:off x="6553200" y="4767263"/>
-            <a:ext cx="2133600" cy="273844"/>
+            <a:off x="6553200" y="6356350"/>
+            <a:ext cx="2133600" cy="365125"/>
           </a:xfrm>
           <a:prstGeom prst="rect">
             <a:avLst/>
@@ -3343,7 +2789,7 @@
           <a:bodyPr vert="horz" lIns="91440" tIns="45720" rIns="91440" bIns="45720" rtlCol="0" anchor="ctr"/>
           <a:lstStyle>
             <a:lvl1pPr algn="r">
-              <a:defRPr sz="900">
+              <a:defRPr sz="1200">
                 <a:solidFill>
                   <a:schemeClr val="tx1">
                     <a:tint val="75000"/>
@@ -3353,7 +2799,7 @@
             </a:lvl1pPr>
           </a:lstStyle>
           <a:p>
-            <a:fld id="{C5EF2332-01BF-834F-8236-50238282D533}" type="slidenum">
+            <a:fld id="{C1FF6DA9-008F-8B48-92A6-B652298478BF}" type="slidenum">
               <a:rPr lang="en-US" smtClean="0"/>
               <a:t>‹#›</a:t>
             </a:fld>
@@ -3364,7 +2810,7 @@
     </p:spTree>
     <p:extLst>
       <p:ext uri="{BB962C8B-B14F-4D97-AF65-F5344CB8AC3E}">
-        <p14:creationId xmlns:p14="http://schemas.microsoft.com/office/powerpoint/2010/main" val="3676200875"/>
+        <p14:creationId xmlns:p14="http://schemas.microsoft.com/office/powerpoint/2010/main" val="2209977519"/>
       </p:ext>
     </p:extLst>
   </p:cSld>
@@ -3384,12 +2830,12 @@
   </p:sldLayoutIdLst>
   <p:txStyles>
     <p:titleStyle>
-      <a:lvl1pPr algn="ctr" defTabSz="342900" rtl="0" eaLnBrk="1" latinLnBrk="0" hangingPunct="1">
+      <a:lvl1pPr algn="ctr" defTabSz="457200" rtl="0" eaLnBrk="1" latinLnBrk="0" hangingPunct="1">
         <a:spcBef>
           <a:spcPct val="0"/>
         </a:spcBef>
         <a:buNone/>
-        <a:defRPr sz="3300" kern="1200">
+        <a:defRPr sz="4400" kern="1200">
           <a:solidFill>
             <a:schemeClr val="tx1"/>
           </a:solidFill>
@@ -3400,7 +2846,37 @@
       </a:lvl1pPr>
     </p:titleStyle>
     <p:bodyStyle>
-      <a:lvl1pPr marL="342900" indent="-342900" algn="l" defTabSz="342900" rtl="0" eaLnBrk="1" latinLnBrk="0" hangingPunct="1">
+      <a:lvl1pPr marL="342900" indent="-342900" algn="l" defTabSz="457200" rtl="0" eaLnBrk="1" latinLnBrk="0" hangingPunct="1">
+        <a:spcBef>
+          <a:spcPct val="20000"/>
+        </a:spcBef>
+        <a:buFont typeface="Arial"/>
+        <a:buChar char="•"/>
+        <a:defRPr sz="3200" kern="1200">
+          <a:solidFill>
+            <a:schemeClr val="tx1"/>
+          </a:solidFill>
+          <a:latin typeface="+mn-lt"/>
+          <a:ea typeface="+mn-ea"/>
+          <a:cs typeface="+mn-cs"/>
+        </a:defRPr>
+      </a:lvl1pPr>
+      <a:lvl2pPr marL="742950" indent="-285750" algn="l" defTabSz="457200" rtl="0" eaLnBrk="1" latinLnBrk="0" hangingPunct="1">
+        <a:spcBef>
+          <a:spcPct val="20000"/>
+        </a:spcBef>
+        <a:buFont typeface="Arial"/>
+        <a:buChar char="–"/>
+        <a:defRPr sz="2800" kern="1200">
+          <a:solidFill>
+            <a:schemeClr val="tx1"/>
+          </a:solidFill>
+          <a:latin typeface="+mn-lt"/>
+          <a:ea typeface="+mn-ea"/>
+          <a:cs typeface="+mn-cs"/>
+        </a:defRPr>
+      </a:lvl2pPr>
+      <a:lvl3pPr marL="1143000" indent="-228600" algn="l" defTabSz="457200" rtl="0" eaLnBrk="1" latinLnBrk="0" hangingPunct="1">
         <a:spcBef>
           <a:spcPct val="20000"/>
         </a:spcBef>
@@ -3414,44 +2890,14 @@
           <a:ea typeface="+mn-ea"/>
           <a:cs typeface="+mn-cs"/>
         </a:defRPr>
-      </a:lvl1pPr>
-      <a:lvl2pPr marL="685800" indent="-342900" algn="l" defTabSz="342900" rtl="0" eaLnBrk="1" latinLnBrk="0" hangingPunct="1">
+      </a:lvl3pPr>
+      <a:lvl4pPr marL="1600200" indent="-228600" algn="l" defTabSz="457200" rtl="0" eaLnBrk="1" latinLnBrk="0" hangingPunct="1">
         <a:spcBef>
           <a:spcPct val="20000"/>
         </a:spcBef>
         <a:buFont typeface="Arial"/>
         <a:buChar char="–"/>
-        <a:defRPr sz="2100" kern="1200">
-          <a:solidFill>
-            <a:schemeClr val="tx1"/>
-          </a:solidFill>
-          <a:latin typeface="+mn-lt"/>
-          <a:ea typeface="+mn-ea"/>
-          <a:cs typeface="+mn-cs"/>
-        </a:defRPr>
-      </a:lvl2pPr>
-      <a:lvl3pPr marL="1028700" indent="-342900" algn="l" defTabSz="342900" rtl="0" eaLnBrk="1" latinLnBrk="0" hangingPunct="1">
-        <a:spcBef>
-          <a:spcPct val="20000"/>
-        </a:spcBef>
-        <a:buFont typeface="Arial"/>
-        <a:buChar char="•"/>
-        <a:defRPr sz="1800" kern="1200">
-          <a:solidFill>
-            <a:schemeClr val="tx1"/>
-          </a:solidFill>
-          <a:latin typeface="+mn-lt"/>
-          <a:ea typeface="+mn-ea"/>
-          <a:cs typeface="+mn-cs"/>
-        </a:defRPr>
-      </a:lvl3pPr>
-      <a:lvl4pPr marL="1371600" indent="-342900" algn="l" defTabSz="342900" rtl="0" eaLnBrk="1" latinLnBrk="0" hangingPunct="1">
-        <a:spcBef>
-          <a:spcPct val="20000"/>
-        </a:spcBef>
-        <a:buFont typeface="Arial"/>
-        <a:buChar char="–"/>
-        <a:defRPr sz="1500" kern="1200">
+        <a:defRPr sz="2000" kern="1200">
           <a:solidFill>
             <a:schemeClr val="tx1"/>
           </a:solidFill>
@@ -3460,13 +2906,13 @@
           <a:cs typeface="+mn-cs"/>
         </a:defRPr>
       </a:lvl4pPr>
-      <a:lvl5pPr marL="1714500" indent="-342900" algn="l" defTabSz="342900" rtl="0" eaLnBrk="1" latinLnBrk="0" hangingPunct="1">
+      <a:lvl5pPr marL="2057400" indent="-228600" algn="l" defTabSz="457200" rtl="0" eaLnBrk="1" latinLnBrk="0" hangingPunct="1">
         <a:spcBef>
           <a:spcPct val="20000"/>
         </a:spcBef>
         <a:buFont typeface="Arial"/>
         <a:buChar char="»"/>
-        <a:defRPr sz="1500" kern="1200">
+        <a:defRPr sz="2000" kern="1200">
           <a:solidFill>
             <a:schemeClr val="tx1"/>
           </a:solidFill>
@@ -3475,13 +2921,13 @@
           <a:cs typeface="+mn-cs"/>
         </a:defRPr>
       </a:lvl5pPr>
-      <a:lvl6pPr marL="2057400" indent="-342900" algn="l" defTabSz="342900" rtl="0" eaLnBrk="1" latinLnBrk="0" hangingPunct="1">
+      <a:lvl6pPr marL="2514600" indent="-228600" algn="l" defTabSz="457200" rtl="0" eaLnBrk="1" latinLnBrk="0" hangingPunct="1">
         <a:spcBef>
           <a:spcPct val="20000"/>
         </a:spcBef>
         <a:buFont typeface="Arial"/>
         <a:buChar char="•"/>
-        <a:defRPr sz="1500" kern="1200">
+        <a:defRPr sz="2000" kern="1200">
           <a:solidFill>
             <a:schemeClr val="tx1"/>
           </a:solidFill>
@@ -3490,13 +2936,13 @@
           <a:cs typeface="+mn-cs"/>
         </a:defRPr>
       </a:lvl6pPr>
-      <a:lvl7pPr marL="2400300" indent="-342900" algn="l" defTabSz="342900" rtl="0" eaLnBrk="1" latinLnBrk="0" hangingPunct="1">
+      <a:lvl7pPr marL="2971800" indent="-228600" algn="l" defTabSz="457200" rtl="0" eaLnBrk="1" latinLnBrk="0" hangingPunct="1">
         <a:spcBef>
           <a:spcPct val="20000"/>
         </a:spcBef>
         <a:buFont typeface="Arial"/>
         <a:buChar char="•"/>
-        <a:defRPr sz="1500" kern="1200">
+        <a:defRPr sz="2000" kern="1200">
           <a:solidFill>
             <a:schemeClr val="tx1"/>
           </a:solidFill>
@@ -3505,13 +2951,13 @@
           <a:cs typeface="+mn-cs"/>
         </a:defRPr>
       </a:lvl7pPr>
-      <a:lvl8pPr marL="2743200" indent="-342900" algn="l" defTabSz="342900" rtl="0" eaLnBrk="1" latinLnBrk="0" hangingPunct="1">
+      <a:lvl8pPr marL="3429000" indent="-228600" algn="l" defTabSz="457200" rtl="0" eaLnBrk="1" latinLnBrk="0" hangingPunct="1">
         <a:spcBef>
           <a:spcPct val="20000"/>
         </a:spcBef>
         <a:buFont typeface="Arial"/>
         <a:buChar char="•"/>
-        <a:defRPr sz="1500" kern="1200">
+        <a:defRPr sz="2000" kern="1200">
           <a:solidFill>
             <a:schemeClr val="tx1"/>
           </a:solidFill>
@@ -3520,13 +2966,13 @@
           <a:cs typeface="+mn-cs"/>
         </a:defRPr>
       </a:lvl8pPr>
-      <a:lvl9pPr marL="3086100" indent="-342900" algn="l" defTabSz="342900" rtl="0" eaLnBrk="1" latinLnBrk="0" hangingPunct="1">
+      <a:lvl9pPr marL="3886200" indent="-228600" algn="l" defTabSz="457200" rtl="0" eaLnBrk="1" latinLnBrk="0" hangingPunct="1">
         <a:spcBef>
           <a:spcPct val="20000"/>
         </a:spcBef>
         <a:buFont typeface="Arial"/>
         <a:buChar char="•"/>
-        <a:defRPr sz="1500" kern="1200">
+        <a:defRPr sz="2000" kern="1200">
           <a:solidFill>
             <a:schemeClr val="tx1"/>
           </a:solidFill>
@@ -3540,8 +2986,8 @@
       <a:defPPr>
         <a:defRPr lang="en-US"/>
       </a:defPPr>
-      <a:lvl1pPr marL="0" algn="l" defTabSz="342900" rtl="0" eaLnBrk="1" latinLnBrk="0" hangingPunct="1">
-        <a:defRPr sz="1350" kern="1200">
+      <a:lvl1pPr marL="0" algn="l" defTabSz="457200" rtl="0" eaLnBrk="1" latinLnBrk="0" hangingPunct="1">
+        <a:defRPr sz="1800" kern="1200">
           <a:solidFill>
             <a:schemeClr val="tx1"/>
           </a:solidFill>
@@ -3550,8 +2996,8 @@
           <a:cs typeface="+mn-cs"/>
         </a:defRPr>
       </a:lvl1pPr>
-      <a:lvl2pPr marL="342900" algn="l" defTabSz="342900" rtl="0" eaLnBrk="1" latinLnBrk="0" hangingPunct="1">
-        <a:defRPr sz="1350" kern="1200">
+      <a:lvl2pPr marL="457200" algn="l" defTabSz="457200" rtl="0" eaLnBrk="1" latinLnBrk="0" hangingPunct="1">
+        <a:defRPr sz="1800" kern="1200">
           <a:solidFill>
             <a:schemeClr val="tx1"/>
           </a:solidFill>
@@ -3560,8 +3006,8 @@
           <a:cs typeface="+mn-cs"/>
         </a:defRPr>
       </a:lvl2pPr>
-      <a:lvl3pPr marL="685800" algn="l" defTabSz="342900" rtl="0" eaLnBrk="1" latinLnBrk="0" hangingPunct="1">
-        <a:defRPr sz="1350" kern="1200">
+      <a:lvl3pPr marL="914400" algn="l" defTabSz="457200" rtl="0" eaLnBrk="1" latinLnBrk="0" hangingPunct="1">
+        <a:defRPr sz="1800" kern="1200">
           <a:solidFill>
             <a:schemeClr val="tx1"/>
           </a:solidFill>
@@ -3570,8 +3016,8 @@
           <a:cs typeface="+mn-cs"/>
         </a:defRPr>
       </a:lvl3pPr>
-      <a:lvl4pPr marL="1028700" algn="l" defTabSz="342900" rtl="0" eaLnBrk="1" latinLnBrk="0" hangingPunct="1">
-        <a:defRPr sz="1350" kern="1200">
+      <a:lvl4pPr marL="1371600" algn="l" defTabSz="457200" rtl="0" eaLnBrk="1" latinLnBrk="0" hangingPunct="1">
+        <a:defRPr sz="1800" kern="1200">
           <a:solidFill>
             <a:schemeClr val="tx1"/>
           </a:solidFill>
@@ -3580,8 +3026,8 @@
           <a:cs typeface="+mn-cs"/>
         </a:defRPr>
       </a:lvl4pPr>
-      <a:lvl5pPr marL="1371600" algn="l" defTabSz="342900" rtl="0" eaLnBrk="1" latinLnBrk="0" hangingPunct="1">
-        <a:defRPr sz="1350" kern="1200">
+      <a:lvl5pPr marL="1828800" algn="l" defTabSz="457200" rtl="0" eaLnBrk="1" latinLnBrk="0" hangingPunct="1">
+        <a:defRPr sz="1800" kern="1200">
           <a:solidFill>
             <a:schemeClr val="tx1"/>
           </a:solidFill>
@@ -3590,8 +3036,8 @@
           <a:cs typeface="+mn-cs"/>
         </a:defRPr>
       </a:lvl5pPr>
-      <a:lvl6pPr marL="1714500" algn="l" defTabSz="342900" rtl="0" eaLnBrk="1" latinLnBrk="0" hangingPunct="1">
-        <a:defRPr sz="1350" kern="1200">
+      <a:lvl6pPr marL="2286000" algn="l" defTabSz="457200" rtl="0" eaLnBrk="1" latinLnBrk="0" hangingPunct="1">
+        <a:defRPr sz="1800" kern="1200">
           <a:solidFill>
             <a:schemeClr val="tx1"/>
           </a:solidFill>
@@ -3600,8 +3046,8 @@
           <a:cs typeface="+mn-cs"/>
         </a:defRPr>
       </a:lvl6pPr>
-      <a:lvl7pPr marL="2057400" algn="l" defTabSz="342900" rtl="0" eaLnBrk="1" latinLnBrk="0" hangingPunct="1">
-        <a:defRPr sz="1350" kern="1200">
+      <a:lvl7pPr marL="2743200" algn="l" defTabSz="457200" rtl="0" eaLnBrk="1" latinLnBrk="0" hangingPunct="1">
+        <a:defRPr sz="1800" kern="1200">
           <a:solidFill>
             <a:schemeClr val="tx1"/>
           </a:solidFill>
@@ -3610,8 +3056,8 @@
           <a:cs typeface="+mn-cs"/>
         </a:defRPr>
       </a:lvl7pPr>
-      <a:lvl8pPr marL="2400300" algn="l" defTabSz="342900" rtl="0" eaLnBrk="1" latinLnBrk="0" hangingPunct="1">
-        <a:defRPr sz="1350" kern="1200">
+      <a:lvl8pPr marL="3200400" algn="l" defTabSz="457200" rtl="0" eaLnBrk="1" latinLnBrk="0" hangingPunct="1">
+        <a:defRPr sz="1800" kern="1200">
           <a:solidFill>
             <a:schemeClr val="tx1"/>
           </a:solidFill>
@@ -3620,8 +3066,8 @@
           <a:cs typeface="+mn-cs"/>
         </a:defRPr>
       </a:lvl8pPr>
-      <a:lvl9pPr marL="2743200" algn="l" defTabSz="342900" rtl="0" eaLnBrk="1" latinLnBrk="0" hangingPunct="1">
-        <a:defRPr sz="1350" kern="1200">
+      <a:lvl9pPr marL="3657600" algn="l" defTabSz="457200" rtl="0" eaLnBrk="1" latinLnBrk="0" hangingPunct="1">
+        <a:defRPr sz="1800" kern="1200">
           <a:solidFill>
             <a:schemeClr val="tx1"/>
           </a:solidFill>
@@ -3636,22 +3082,23 @@
 </file>
 
 <file path=ppt/slides/slide1.xml><?xml version="1.0" encoding="utf-8"?>
-<p:sld xmlns:a="http://schemas.openxmlformats.org/drawingml/2006/main" xmlns:r="http://schemas.openxmlformats.org/officeDocument/2006/relationships" xmlns:p="http://schemas.openxmlformats.org/presentationml/2006/main">
+<p:sld xmlns:a="http://schemas.openxmlformats.org/drawingml/2006/main" xmlns:p="http://schemas.openxmlformats.org/presentationml/2006/main" xmlns:r="http://schemas.openxmlformats.org/officeDocument/2006/relationships">
   <p:cSld>
+    <p:bg>
+      <p:bgPr>
+        <a:solidFill>
+          <a:srgbClr val="001E2B"/>
+        </a:solidFill>
+        <a:effectLst/>
+      </p:bgPr>
+    </p:bg>
     <p:spTree>
       <p:nvGrpSpPr>
         <p:cNvPr id="1" name=""/>
         <p:cNvGrpSpPr/>
         <p:nvPr/>
       </p:nvGrpSpPr>
-      <p:grpSpPr>
-        <a:xfrm>
-          <a:off x="0" y="0"/>
-          <a:ext cx="0" cy="0"/>
-          <a:chOff x="0" y="0"/>
-          <a:chExt cx="0" cy="0"/>
-        </a:xfrm>
-      </p:grpSpPr>
+      <p:grpSpPr/>
       <p:sp>
         <p:nvSpPr>
           <p:cNvPr id="2" name="Title 1"/>
@@ -3666,9 +3113,140 @@
         <p:txBody>
           <a:bodyPr/>
           <a:lstStyle/>
-          <a:p>
-            <a:r>
-              <a:rPr lang="en-US" dirty="0"/>
+          <a:p/>
+        </p:txBody>
+      </p:sp>
+      <p:sp>
+        <p:nvSpPr>
+          <p:cNvPr id="3" name="Subtitle 2"/>
+          <p:cNvSpPr>
+            <a:spLocks noGrp="1"/>
+          </p:cNvSpPr>
+          <p:nvPr>
+            <p:ph type="subTitle" idx="1"/>
+          </p:nvPr>
+        </p:nvSpPr>
+        <p:spPr/>
+        <p:txBody>
+          <a:bodyPr/>
+          <a:lstStyle/>
+          <a:p/>
+        </p:txBody>
+      </p:sp>
+      <p:sp>
+        <p:nvSpPr>
+          <p:cNvPr id="4" name="Rectangle 3"/>
+          <p:cNvSpPr/>
+          <p:nvPr/>
+        </p:nvSpPr>
+        <p:spPr>
+          <a:xfrm>
+            <a:off x="0" y="6693408"/>
+            <a:ext cx="12188952" cy="164592"/>
+          </a:xfrm>
+          <a:prstGeom prst="rect">
+            <a:avLst/>
+          </a:prstGeom>
+          <a:solidFill>
+            <a:srgbClr val="00ED64"/>
+          </a:solidFill>
+          <a:ln>
+            <a:noFill/>
+          </a:ln>
+        </p:spPr>
+        <p:style>
+          <a:lnRef idx="1">
+            <a:schemeClr val="accent1"/>
+          </a:lnRef>
+          <a:fillRef idx="3">
+            <a:schemeClr val="accent1"/>
+          </a:fillRef>
+          <a:effectRef idx="2">
+            <a:schemeClr val="accent1"/>
+          </a:effectRef>
+          <a:fontRef idx="minor">
+            <a:schemeClr val="lt1"/>
+          </a:fontRef>
+        </p:style>
+        <p:txBody>
+          <a:bodyPr rtlCol="0" anchor="ctr"/>
+          <a:lstStyle/>
+          <a:p>
+            <a:pPr algn="ctr"/>
+          </a:p>
+        </p:txBody>
+      </p:sp>
+      <p:sp>
+        <p:nvSpPr>
+          <p:cNvPr id="5" name="Rectangle 4"/>
+          <p:cNvSpPr/>
+          <p:nvPr/>
+        </p:nvSpPr>
+        <p:spPr>
+          <a:xfrm>
+            <a:off x="0" y="0"/>
+            <a:ext cx="12188952" cy="73152"/>
+          </a:xfrm>
+          <a:prstGeom prst="rect">
+            <a:avLst/>
+          </a:prstGeom>
+          <a:solidFill>
+            <a:srgbClr val="00ED64"/>
+          </a:solidFill>
+          <a:ln>
+            <a:noFill/>
+          </a:ln>
+        </p:spPr>
+        <p:style>
+          <a:lnRef idx="1">
+            <a:schemeClr val="accent1"/>
+          </a:lnRef>
+          <a:fillRef idx="3">
+            <a:schemeClr val="accent1"/>
+          </a:fillRef>
+          <a:effectRef idx="2">
+            <a:schemeClr val="accent1"/>
+          </a:effectRef>
+          <a:fontRef idx="minor">
+            <a:schemeClr val="lt1"/>
+          </a:fontRef>
+        </p:style>
+        <p:txBody>
+          <a:bodyPr rtlCol="0" anchor="ctr"/>
+          <a:lstStyle/>
+          <a:p>
+            <a:pPr algn="ctr"/>
+          </a:p>
+        </p:txBody>
+      </p:sp>
+      <p:sp>
+        <p:nvSpPr>
+          <p:cNvPr id="6" name="TextBox 5"/>
+          <p:cNvSpPr txBox="1"/>
+          <p:nvPr/>
+        </p:nvSpPr>
+        <p:spPr>
+          <a:xfrm>
+            <a:off x="1097280" y="2194560"/>
+            <a:ext cx="9966960" cy="1371600"/>
+          </a:xfrm>
+          <a:prstGeom prst="rect">
+            <a:avLst/>
+          </a:prstGeom>
+          <a:noFill/>
+        </p:spPr>
+        <p:txBody>
+          <a:bodyPr wrap="square"/>
+          <a:lstStyle/>
+          <a:p>
+            <a:pPr algn="ctr"/>
+            <a:r>
+              <a:rPr sz="4400" b="1">
+                <a:solidFill>
+                  <a:srgbClr val="00ED64"/>
+                </a:solidFill>
+                <a:latin typeface="Calibri"/>
+              </a:rPr>
               <a:t>Presentation Title</a:t>
             </a:r>
           </a:p>
@@ -3676,32 +3254,38 @@
       </p:sp>
       <p:sp>
         <p:nvSpPr>
-          <p:cNvPr id="3" name="Subtitle 2"/>
-          <p:cNvSpPr>
-            <a:spLocks noGrp="1"/>
-          </p:cNvSpPr>
-          <p:nvPr>
-            <p:ph type="subTitle" idx="1"/>
-          </p:nvPr>
-        </p:nvSpPr>
-        <p:spPr/>
-        <p:txBody>
-          <a:bodyPr/>
-          <a:lstStyle/>
-          <a:p>
-            <a:r>
-              <a:rPr lang="en-US" dirty="0"/>
-              <a:t>Presentation Subtitle</a:t>
+          <p:cNvPr id="7" name="TextBox 6"/>
+          <p:cNvSpPr txBox="1"/>
+          <p:nvPr/>
+        </p:nvSpPr>
+        <p:spPr>
+          <a:xfrm>
+            <a:off x="1097280" y="3657600"/>
+            <a:ext cx="9966960" cy="731520"/>
+          </a:xfrm>
+          <a:prstGeom prst="rect">
+            <a:avLst/>
+          </a:prstGeom>
+          <a:noFill/>
+        </p:spPr>
+        <p:txBody>
+          <a:bodyPr wrap="square"/>
+          <a:lstStyle/>
+          <a:p>
+            <a:pPr algn="ctr"/>
+            <a:r>
+              <a:rPr sz="2200" b="0">
+                <a:solidFill>
+                  <a:srgbClr val="CCCCCC"/>
+                </a:solidFill>
+                <a:latin typeface="Calibri"/>
+              </a:rPr>
+              <a:t>Subtitle · Author · Date</a:t>
             </a:r>
           </a:p>
         </p:txBody>
       </p:sp>
     </p:spTree>
-    <p:extLst>
-      <p:ext uri="{BB962C8B-B14F-4D97-AF65-F5344CB8AC3E}">
-        <p14:creationId xmlns:p14="http://schemas.microsoft.com/office/powerpoint/2010/main" val="392669009"/>
-      </p:ext>
-    </p:extLst>
   </p:cSld>
   <p:clrMapOvr>
     <a:masterClrMapping/>
@@ -3710,22 +3294,23 @@
 </file>
 
 <file path=ppt/slides/slide2.xml><?xml version="1.0" encoding="utf-8"?>
-<p:sld xmlns:a="http://schemas.openxmlformats.org/drawingml/2006/main" xmlns:r="http://schemas.openxmlformats.org/officeDocument/2006/relationships" xmlns:p="http://schemas.openxmlformats.org/presentationml/2006/main">
+<p:sld xmlns:a="http://schemas.openxmlformats.org/drawingml/2006/main" xmlns:p="http://schemas.openxmlformats.org/presentationml/2006/main" xmlns:r="http://schemas.openxmlformats.org/officeDocument/2006/relationships">
   <p:cSld>
+    <p:bg>
+      <p:bgPr>
+        <a:solidFill>
+          <a:srgbClr val="001E2B"/>
+        </a:solidFill>
+        <a:effectLst/>
+      </p:bgPr>
+    </p:bg>
     <p:spTree>
       <p:nvGrpSpPr>
         <p:cNvPr id="1" name=""/>
         <p:cNvGrpSpPr/>
         <p:nvPr/>
       </p:nvGrpSpPr>
-      <p:grpSpPr>
-        <a:xfrm>
-          <a:off x="0" y="0"/>
-          <a:ext cx="0" cy="0"/>
-          <a:chOff x="0" y="0"/>
-          <a:chExt cx="0" cy="0"/>
-        </a:xfrm>
-      </p:grpSpPr>
+      <p:grpSpPr/>
       <p:sp>
         <p:nvSpPr>
           <p:cNvPr id="2" name="Title 1"/>
@@ -3740,12 +3325,7 @@
         <p:txBody>
           <a:bodyPr/>
           <a:lstStyle/>
-          <a:p>
-            <a:r>
-              <a:rPr lang="en-US" dirty="0"/>
-              <a:t>Slide Title</a:t>
-            </a:r>
-          </a:p>
+          <a:p/>
         </p:txBody>
       </p:sp>
       <p:sp>
@@ -3762,27 +3342,208 @@
         <p:txBody>
           <a:bodyPr/>
           <a:lstStyle/>
-          <a:p>
-            <a:pPr marL="0" indent="0">
-              <a:buNone/>
-            </a:pPr>
-            <a:r>
-              <a:rPr lang="en-US" dirty="0"/>
-              <a:t>Hello</a:t>
-            </a:r>
-            <a:r>
-              <a:rPr lang="en-US"/>
-              <a:t>, world.</a:t>
+          <a:p/>
+        </p:txBody>
+      </p:sp>
+      <p:sp>
+        <p:nvSpPr>
+          <p:cNvPr id="4" name="Rectangle 3"/>
+          <p:cNvSpPr/>
+          <p:nvPr/>
+        </p:nvSpPr>
+        <p:spPr>
+          <a:xfrm>
+            <a:off x="0" y="0"/>
+            <a:ext cx="12188952" cy="73152"/>
+          </a:xfrm>
+          <a:prstGeom prst="rect">
+            <a:avLst/>
+          </a:prstGeom>
+          <a:solidFill>
+            <a:srgbClr val="00ED64"/>
+          </a:solidFill>
+          <a:ln>
+            <a:noFill/>
+          </a:ln>
+        </p:spPr>
+        <p:style>
+          <a:lnRef idx="1">
+            <a:schemeClr val="accent1"/>
+          </a:lnRef>
+          <a:fillRef idx="3">
+            <a:schemeClr val="accent1"/>
+          </a:fillRef>
+          <a:effectRef idx="2">
+            <a:schemeClr val="accent1"/>
+          </a:effectRef>
+          <a:fontRef idx="minor">
+            <a:schemeClr val="lt1"/>
+          </a:fontRef>
+        </p:style>
+        <p:txBody>
+          <a:bodyPr rtlCol="0" anchor="ctr"/>
+          <a:lstStyle/>
+          <a:p>
+            <a:pPr algn="ctr"/>
+          </a:p>
+        </p:txBody>
+      </p:sp>
+      <p:sp>
+        <p:nvSpPr>
+          <p:cNvPr id="5" name="Rectangle 4"/>
+          <p:cNvSpPr/>
+          <p:nvPr/>
+        </p:nvSpPr>
+        <p:spPr>
+          <a:xfrm>
+            <a:off x="0" y="6748272"/>
+            <a:ext cx="12188952" cy="109728"/>
+          </a:xfrm>
+          <a:prstGeom prst="rect">
+            <a:avLst/>
+          </a:prstGeom>
+          <a:solidFill>
+            <a:srgbClr val="00684A"/>
+          </a:solidFill>
+          <a:ln>
+            <a:noFill/>
+          </a:ln>
+        </p:spPr>
+        <p:style>
+          <a:lnRef idx="1">
+            <a:schemeClr val="accent1"/>
+          </a:lnRef>
+          <a:fillRef idx="3">
+            <a:schemeClr val="accent1"/>
+          </a:fillRef>
+          <a:effectRef idx="2">
+            <a:schemeClr val="accent1"/>
+          </a:effectRef>
+          <a:fontRef idx="minor">
+            <a:schemeClr val="lt1"/>
+          </a:fontRef>
+        </p:style>
+        <p:txBody>
+          <a:bodyPr rtlCol="0" anchor="ctr"/>
+          <a:lstStyle/>
+          <a:p>
+            <a:pPr algn="ctr"/>
+          </a:p>
+        </p:txBody>
+      </p:sp>
+      <p:sp>
+        <p:nvSpPr>
+          <p:cNvPr id="6" name="TextBox 5"/>
+          <p:cNvSpPr txBox="1"/>
+          <p:nvPr/>
+        </p:nvSpPr>
+        <p:spPr>
+          <a:xfrm>
+            <a:off x="548640" y="228600"/>
+            <a:ext cx="10972800" cy="822960"/>
+          </a:xfrm>
+          <a:prstGeom prst="rect">
+            <a:avLst/>
+          </a:prstGeom>
+          <a:noFill/>
+        </p:spPr>
+        <p:txBody>
+          <a:bodyPr wrap="square"/>
+          <a:lstStyle/>
+          <a:p>
+            <a:pPr algn="l"/>
+            <a:r>
+              <a:rPr sz="3200" b="1">
+                <a:solidFill>
+                  <a:srgbClr val="00ED64"/>
+                </a:solidFill>
+                <a:latin typeface="Calibri"/>
+              </a:rPr>
+              <a:t>Content Slide</a:t>
+            </a:r>
+          </a:p>
+        </p:txBody>
+      </p:sp>
+      <p:sp>
+        <p:nvSpPr>
+          <p:cNvPr id="7" name="Rectangle 6"/>
+          <p:cNvSpPr/>
+          <p:nvPr/>
+        </p:nvSpPr>
+        <p:spPr>
+          <a:xfrm>
+            <a:off x="548640" y="1051560"/>
+            <a:ext cx="10972800" cy="36000"/>
+          </a:xfrm>
+          <a:prstGeom prst="rect">
+            <a:avLst/>
+          </a:prstGeom>
+          <a:solidFill>
+            <a:srgbClr val="00684A"/>
+          </a:solidFill>
+          <a:ln>
+            <a:noFill/>
+          </a:ln>
+        </p:spPr>
+        <p:style>
+          <a:lnRef idx="1">
+            <a:schemeClr val="accent1"/>
+          </a:lnRef>
+          <a:fillRef idx="3">
+            <a:schemeClr val="accent1"/>
+          </a:fillRef>
+          <a:effectRef idx="2">
+            <a:schemeClr val="accent1"/>
+          </a:effectRef>
+          <a:fontRef idx="minor">
+            <a:schemeClr val="lt1"/>
+          </a:fontRef>
+        </p:style>
+        <p:txBody>
+          <a:bodyPr rtlCol="0" anchor="ctr"/>
+          <a:lstStyle/>
+          <a:p>
+            <a:pPr algn="ctr"/>
+          </a:p>
+        </p:txBody>
+      </p:sp>
+      <p:sp>
+        <p:nvSpPr>
+          <p:cNvPr id="8" name="TextBox 7"/>
+          <p:cNvSpPr txBox="1"/>
+          <p:nvPr/>
+        </p:nvSpPr>
+        <p:spPr>
+          <a:xfrm>
+            <a:off x="548640" y="1188720"/>
+            <a:ext cx="10972800" cy="5303520"/>
+          </a:xfrm>
+          <a:prstGeom prst="rect">
+            <a:avLst/>
+          </a:prstGeom>
+          <a:noFill/>
+        </p:spPr>
+        <p:txBody>
+          <a:bodyPr wrap="square"/>
+          <a:lstStyle/>
+          <a:p>
+            <a:pPr algn="l"/>
+            <a:r>
+              <a:rPr sz="2200" b="0">
+                <a:solidFill>
+                  <a:srgbClr val="FFFFFF"/>
+                </a:solidFill>
+                <a:latin typeface="Calibri"/>
+              </a:rPr>
+              <a:t>• Main bullet point
+• Supporting detail
+• Another point
+• Keep to 4–6 bullets per slide</a:t>
             </a:r>
           </a:p>
         </p:txBody>
       </p:sp>
     </p:spTree>
-    <p:extLst>
-      <p:ext uri="{BB962C8B-B14F-4D97-AF65-F5344CB8AC3E}">
-        <p14:creationId xmlns:p14="http://schemas.microsoft.com/office/powerpoint/2010/main" val="572707455"/>
-      </p:ext>
-    </p:extLst>
   </p:cSld>
   <p:clrMapOvr>
     <a:masterClrMapping/>
@@ -3791,22 +3552,23 @@
 </file>
 
 <file path=ppt/slides/slide3.xml><?xml version="1.0" encoding="utf-8"?>
-<p:sld xmlns:a="http://schemas.openxmlformats.org/drawingml/2006/main" xmlns:r="http://schemas.openxmlformats.org/officeDocument/2006/relationships" xmlns:p="http://schemas.openxmlformats.org/presentationml/2006/main">
+<p:sld xmlns:a="http://schemas.openxmlformats.org/drawingml/2006/main" xmlns:p="http://schemas.openxmlformats.org/presentationml/2006/main" xmlns:r="http://schemas.openxmlformats.org/officeDocument/2006/relationships">
   <p:cSld>
+    <p:bg>
+      <p:bgPr>
+        <a:solidFill>
+          <a:srgbClr val="001E2B"/>
+        </a:solidFill>
+        <a:effectLst/>
+      </p:bgPr>
+    </p:bg>
     <p:spTree>
       <p:nvGrpSpPr>
         <p:cNvPr id="1" name=""/>
         <p:cNvGrpSpPr/>
         <p:nvPr/>
       </p:nvGrpSpPr>
-      <p:grpSpPr>
-        <a:xfrm>
-          <a:off x="0" y="0"/>
-          <a:ext cx="0" cy="0"/>
-          <a:chOff x="0" y="0"/>
-          <a:chExt cx="0" cy="0"/>
-        </a:xfrm>
-      </p:grpSpPr>
+      <p:grpSpPr/>
       <p:sp>
         <p:nvSpPr>
           <p:cNvPr id="2" name="Title 1"/>
@@ -3821,32 +3583,222 @@
         <p:txBody>
           <a:bodyPr/>
           <a:lstStyle/>
-          <a:p>
-            <a:r>
-              <a:rPr lang="en-US" dirty="0"/>
-              <a:t>Section header</a:t>
-            </a:r>
-          </a:p>
-        </p:txBody>
-      </p:sp>
-      <p:sp>
-        <p:nvSpPr>
-          <p:cNvPr id="3" name="Text Placeholder 2"/>
-          <p:cNvSpPr>
-            <a:spLocks noGrp="1"/>
-          </p:cNvSpPr>
-          <p:nvPr>
-            <p:ph type="body" idx="1"/>
-          </p:nvPr>
-        </p:nvSpPr>
-        <p:spPr/>
+          <a:p/>
+        </p:txBody>
+      </p:sp>
+      <p:sp>
+        <p:nvSpPr>
+          <p:cNvPr id="3" name="Content Placeholder 2"/>
+          <p:cNvSpPr>
+            <a:spLocks noGrp="1"/>
+          </p:cNvSpPr>
+          <p:nvPr>
+            <p:ph idx="1"/>
+          </p:nvPr>
+        </p:nvSpPr>
+        <p:spPr/>
+        <p:txBody>
+          <a:bodyPr/>
+          <a:lstStyle/>
+          <a:p/>
+        </p:txBody>
+      </p:sp>
+      <p:sp>
+        <p:nvSpPr>
+          <p:cNvPr id="4" name="Rectangle 3"/>
+          <p:cNvSpPr/>
+          <p:nvPr/>
+        </p:nvSpPr>
+        <p:spPr>
+          <a:xfrm>
+            <a:off x="0" y="0"/>
+            <a:ext cx="12188952" cy="73152"/>
+          </a:xfrm>
+          <a:prstGeom prst="rect">
+            <a:avLst/>
+          </a:prstGeom>
+          <a:solidFill>
+            <a:srgbClr val="00ED64"/>
+          </a:solidFill>
+          <a:ln>
+            <a:noFill/>
+          </a:ln>
+        </p:spPr>
+        <p:style>
+          <a:lnRef idx="1">
+            <a:schemeClr val="accent1"/>
+          </a:lnRef>
+          <a:fillRef idx="3">
+            <a:schemeClr val="accent1"/>
+          </a:fillRef>
+          <a:effectRef idx="2">
+            <a:schemeClr val="accent1"/>
+          </a:effectRef>
+          <a:fontRef idx="minor">
+            <a:schemeClr val="lt1"/>
+          </a:fontRef>
+        </p:style>
+        <p:txBody>
+          <a:bodyPr rtlCol="0" anchor="ctr"/>
+          <a:lstStyle/>
+          <a:p>
+            <a:pPr algn="ctr"/>
+          </a:p>
+        </p:txBody>
+      </p:sp>
+      <p:sp>
+        <p:nvSpPr>
+          <p:cNvPr id="5" name="Rectangle 4"/>
+          <p:cNvSpPr/>
+          <p:nvPr/>
+        </p:nvSpPr>
+        <p:spPr>
+          <a:xfrm>
+            <a:off x="0" y="6748272"/>
+            <a:ext cx="12188952" cy="109728"/>
+          </a:xfrm>
+          <a:prstGeom prst="rect">
+            <a:avLst/>
+          </a:prstGeom>
+          <a:solidFill>
+            <a:srgbClr val="00684A"/>
+          </a:solidFill>
+          <a:ln>
+            <a:noFill/>
+          </a:ln>
+        </p:spPr>
+        <p:style>
+          <a:lnRef idx="1">
+            <a:schemeClr val="accent1"/>
+          </a:lnRef>
+          <a:fillRef idx="3">
+            <a:schemeClr val="accent1"/>
+          </a:fillRef>
+          <a:effectRef idx="2">
+            <a:schemeClr val="accent1"/>
+          </a:effectRef>
+          <a:fontRef idx="minor">
+            <a:schemeClr val="lt1"/>
+          </a:fontRef>
+        </p:style>
+        <p:txBody>
+          <a:bodyPr rtlCol="0" anchor="ctr"/>
+          <a:lstStyle/>
+          <a:p>
+            <a:pPr algn="ctr"/>
+          </a:p>
+        </p:txBody>
+      </p:sp>
+      <p:sp>
+        <p:nvSpPr>
+          <p:cNvPr id="6" name="TextBox 5"/>
+          <p:cNvSpPr txBox="1"/>
+          <p:nvPr/>
+        </p:nvSpPr>
+        <p:spPr>
+          <a:xfrm>
+            <a:off x="548640" y="228600"/>
+            <a:ext cx="10972800" cy="822960"/>
+          </a:xfrm>
+          <a:prstGeom prst="rect">
+            <a:avLst/>
+          </a:prstGeom>
+          <a:noFill/>
+        </p:spPr>
+        <p:txBody>
+          <a:bodyPr wrap="square"/>
+          <a:lstStyle/>
+          <a:p>
+            <a:pPr algn="l"/>
+            <a:r>
+              <a:rPr sz="3200" b="1">
+                <a:solidFill>
+                  <a:srgbClr val="00ED64"/>
+                </a:solidFill>
+                <a:latin typeface="Calibri"/>
+              </a:rPr>
+              <a:t>Two-Column or Code Slide</a:t>
+            </a:r>
+          </a:p>
+        </p:txBody>
+      </p:sp>
+      <p:sp>
+        <p:nvSpPr>
+          <p:cNvPr id="7" name="Rectangle 6"/>
+          <p:cNvSpPr/>
+          <p:nvPr/>
+        </p:nvSpPr>
+        <p:spPr>
+          <a:xfrm>
+            <a:off x="548640" y="1051560"/>
+            <a:ext cx="10972800" cy="36000"/>
+          </a:xfrm>
+          <a:prstGeom prst="rect">
+            <a:avLst/>
+          </a:prstGeom>
+          <a:solidFill>
+            <a:srgbClr val="00684A"/>
+          </a:solidFill>
+          <a:ln>
+            <a:noFill/>
+          </a:ln>
+        </p:spPr>
+        <p:style>
+          <a:lnRef idx="1">
+            <a:schemeClr val="accent1"/>
+          </a:lnRef>
+          <a:fillRef idx="3">
+            <a:schemeClr val="accent1"/>
+          </a:fillRef>
+          <a:effectRef idx="2">
+            <a:schemeClr val="accent1"/>
+          </a:effectRef>
+          <a:fontRef idx="minor">
+            <a:schemeClr val="lt1"/>
+          </a:fontRef>
+        </p:style>
+        <p:txBody>
+          <a:bodyPr rtlCol="0" anchor="ctr"/>
+          <a:lstStyle/>
+          <a:p>
+            <a:pPr algn="ctr"/>
+          </a:p>
+        </p:txBody>
+      </p:sp>
+      <p:sp>
+        <p:nvSpPr>
+          <p:cNvPr id="8" name="TextBox 7"/>
+          <p:cNvSpPr txBox="1"/>
+          <p:nvPr/>
+        </p:nvSpPr>
+        <p:spPr>
+          <a:xfrm>
+            <a:off x="548640" y="1188720"/>
+            <a:ext cx="10972800" cy="5303520"/>
+          </a:xfrm>
+          <a:prstGeom prst="rect">
+            <a:avLst/>
+          </a:prstGeom>
+          <a:noFill/>
+        </p:spPr>
+        <p:txBody>
+          <a:bodyPr wrap="square"/>
+          <a:lstStyle/>
+          <a:p>
+            <a:pPr algn="l"/>
+            <a:r>
+              <a:rPr sz="2200" b="0">
+                <a:solidFill>
+                  <a:srgbClr val="FFFFFF"/>
+                </a:solidFill>
+                <a:latin typeface="Calibri"/>
+              </a:rPr>
+              <a:t>Code block or two-column layout here</a:t>
+            </a:r>
+          </a:p>
+        </p:txBody>
       </p:sp>
     </p:spTree>
-    <p:extLst>
-      <p:ext uri="{BB962C8B-B14F-4D97-AF65-F5344CB8AC3E}">
-        <p14:creationId xmlns:p14="http://schemas.microsoft.com/office/powerpoint/2010/main" val="3996781534"/>
-      </p:ext>
-    </p:extLst>
   </p:cSld>
   <p:clrMapOvr>
     <a:masterClrMapping/>
@@ -3855,25 +3807,26 @@
 </file>
 
 <file path=ppt/slides/slide4.xml><?xml version="1.0" encoding="utf-8"?>
-<p:sld xmlns:a="http://schemas.openxmlformats.org/drawingml/2006/main" xmlns:r="http://schemas.openxmlformats.org/officeDocument/2006/relationships" xmlns:p="http://schemas.openxmlformats.org/presentationml/2006/main">
+<p:sld xmlns:a="http://schemas.openxmlformats.org/drawingml/2006/main" xmlns:p="http://schemas.openxmlformats.org/presentationml/2006/main" xmlns:r="http://schemas.openxmlformats.org/officeDocument/2006/relationships">
   <p:cSld>
+    <p:bg>
+      <p:bgPr>
+        <a:solidFill>
+          <a:srgbClr val="00684A"/>
+        </a:solidFill>
+        <a:effectLst/>
+      </p:bgPr>
+    </p:bg>
     <p:spTree>
       <p:nvGrpSpPr>
         <p:cNvPr id="1" name=""/>
         <p:cNvGrpSpPr/>
         <p:nvPr/>
       </p:nvGrpSpPr>
-      <p:grpSpPr>
-        <a:xfrm>
-          <a:off x="0" y="0"/>
-          <a:ext cx="0" cy="0"/>
-          <a:chOff x="0" y="0"/>
-          <a:chExt cx="0" cy="0"/>
-        </a:xfrm>
-      </p:grpSpPr>
-      <p:sp>
-        <p:nvSpPr>
-          <p:cNvPr id="4" name="Title 3"/>
+      <p:grpSpPr/>
+      <p:sp>
+        <p:nvSpPr>
+          <p:cNvPr id="2" name="Title 1"/>
           <p:cNvSpPr>
             <a:spLocks noGrp="1"/>
           </p:cNvSpPr>
@@ -3885,75 +3838,103 @@
         <p:txBody>
           <a:bodyPr/>
           <a:lstStyle/>
-          <a:p>
-            <a:r>
-              <a:rPr lang="en-US" dirty="0"/>
-              <a:t>Slide Title for Two-Content</a:t>
-            </a:r>
-          </a:p>
-        </p:txBody>
-      </p:sp>
-      <p:sp>
-        <p:nvSpPr>
-          <p:cNvPr id="5" name="Content Placeholder 4"/>
-          <p:cNvSpPr>
-            <a:spLocks noGrp="1"/>
-          </p:cNvSpPr>
-          <p:nvPr>
-            <p:ph sz="half" idx="1"/>
-          </p:nvPr>
-        </p:nvSpPr>
-        <p:spPr/>
-        <p:txBody>
-          <a:bodyPr/>
-          <a:lstStyle/>
-          <a:p>
-            <a:r>
-              <a:rPr lang="en-US" dirty="0"/>
-              <a:t>Some content on </a:t>
-            </a:r>
-            <a:r>
-              <a:rPr lang="en-US"/>
-              <a:t>the left.</a:t>
-            </a:r>
-            <a:endParaRPr lang="en-US" dirty="0"/>
-          </a:p>
-          <a:p>
-            <a:pPr marL="0" indent="0">
-              <a:buNone/>
-            </a:pPr>
-            <a:endParaRPr lang="en-US" dirty="0"/>
-          </a:p>
-        </p:txBody>
-      </p:sp>
-      <p:sp>
-        <p:nvSpPr>
-          <p:cNvPr id="6" name="Content Placeholder 5"/>
-          <p:cNvSpPr>
-            <a:spLocks noGrp="1"/>
-          </p:cNvSpPr>
-          <p:nvPr>
-            <p:ph sz="half" idx="2"/>
-          </p:nvPr>
-        </p:nvSpPr>
-        <p:spPr/>
-        <p:txBody>
-          <a:bodyPr/>
-          <a:lstStyle/>
-          <a:p>
-            <a:r>
-              <a:rPr lang="en-US" dirty="0"/>
-              <a:t>Some content on the right.</a:t>
+          <a:p/>
+        </p:txBody>
+      </p:sp>
+      <p:sp>
+        <p:nvSpPr>
+          <p:cNvPr id="3" name="Content Placeholder 2"/>
+          <p:cNvSpPr>
+            <a:spLocks noGrp="1"/>
+          </p:cNvSpPr>
+          <p:nvPr>
+            <p:ph idx="1"/>
+          </p:nvPr>
+        </p:nvSpPr>
+        <p:spPr/>
+        <p:txBody>
+          <a:bodyPr/>
+          <a:lstStyle/>
+          <a:p/>
+        </p:txBody>
+      </p:sp>
+      <p:sp>
+        <p:nvSpPr>
+          <p:cNvPr id="4" name="Rectangle 3"/>
+          <p:cNvSpPr/>
+          <p:nvPr/>
+        </p:nvSpPr>
+        <p:spPr>
+          <a:xfrm>
+            <a:off x="0" y="6629400"/>
+            <a:ext cx="12188952" cy="228600"/>
+          </a:xfrm>
+          <a:prstGeom prst="rect">
+            <a:avLst/>
+          </a:prstGeom>
+          <a:solidFill>
+            <a:srgbClr val="00ED64"/>
+          </a:solidFill>
+          <a:ln>
+            <a:noFill/>
+          </a:ln>
+        </p:spPr>
+        <p:style>
+          <a:lnRef idx="1">
+            <a:schemeClr val="accent1"/>
+          </a:lnRef>
+          <a:fillRef idx="3">
+            <a:schemeClr val="accent1"/>
+          </a:fillRef>
+          <a:effectRef idx="2">
+            <a:schemeClr val="accent1"/>
+          </a:effectRef>
+          <a:fontRef idx="minor">
+            <a:schemeClr val="lt1"/>
+          </a:fontRef>
+        </p:style>
+        <p:txBody>
+          <a:bodyPr rtlCol="0" anchor="ctr"/>
+          <a:lstStyle/>
+          <a:p>
+            <a:pPr algn="ctr"/>
+          </a:p>
+        </p:txBody>
+      </p:sp>
+      <p:sp>
+        <p:nvSpPr>
+          <p:cNvPr id="5" name="TextBox 4"/>
+          <p:cNvSpPr txBox="1"/>
+          <p:nvPr/>
+        </p:nvSpPr>
+        <p:spPr>
+          <a:xfrm>
+            <a:off x="914400" y="2560320"/>
+            <a:ext cx="10332720" cy="1371600"/>
+          </a:xfrm>
+          <a:prstGeom prst="rect">
+            <a:avLst/>
+          </a:prstGeom>
+          <a:noFill/>
+        </p:spPr>
+        <p:txBody>
+          <a:bodyPr wrap="square"/>
+          <a:lstStyle/>
+          <a:p>
+            <a:pPr algn="ctr"/>
+            <a:r>
+              <a:rPr sz="4000" b="1">
+                <a:solidFill>
+                  <a:srgbClr val="FFFFFF"/>
+                </a:solidFill>
+                <a:latin typeface="Calibri"/>
+              </a:rPr>
+              <a:t>Section Break</a:t>
             </a:r>
           </a:p>
         </p:txBody>
       </p:sp>
     </p:spTree>
-    <p:extLst>
-      <p:ext uri="{BB962C8B-B14F-4D97-AF65-F5344CB8AC3E}">
-        <p14:creationId xmlns:p14="http://schemas.microsoft.com/office/powerpoint/2010/main" val="1324621109"/>
-      </p:ext>
-    </p:extLst>
   </p:cSld>
   <p:clrMapOvr>
     <a:masterClrMapping/>
@@ -4279,265 +4260,4 @@
   </a:objectDefaults>
   <a:extraClrSchemeLst/>
 </a:theme>
-</file>
-
-<file path=ppt/theme/theme2.xml><?xml version="1.0" encoding="utf-8"?>
-<a:theme xmlns:a="http://schemas.openxmlformats.org/drawingml/2006/main" name="Office Theme">
-  <a:themeElements>
-    <a:clrScheme name="Office">
-      <a:dk1>
-        <a:sysClr val="windowText" lastClr="000000"/>
-      </a:dk1>
-      <a:lt1>
-        <a:sysClr val="window" lastClr="FFFFFF"/>
-      </a:lt1>
-      <a:dk2>
-        <a:srgbClr val="44546A"/>
-      </a:dk2>
-      <a:lt2>
-        <a:srgbClr val="E7E6E6"/>
-      </a:lt2>
-      <a:accent1>
-        <a:srgbClr val="5B9BD5"/>
-      </a:accent1>
-      <a:accent2>
-        <a:srgbClr val="ED7D31"/>
-      </a:accent2>
-      <a:accent3>
-        <a:srgbClr val="A5A5A5"/>
-      </a:accent3>
-      <a:accent4>
-        <a:srgbClr val="FFC000"/>
-      </a:accent4>
-      <a:accent5>
-        <a:srgbClr val="4472C4"/>
-      </a:accent5>
-      <a:accent6>
-        <a:srgbClr val="70AD47"/>
-      </a:accent6>
-      <a:hlink>
-        <a:srgbClr val="0563C1"/>
-      </a:hlink>
-      <a:folHlink>
-        <a:srgbClr val="954F72"/>
-      </a:folHlink>
-    </a:clrScheme>
-    <a:fontScheme name="Office">
-      <a:majorFont>
-        <a:latin typeface="Calibri Light" panose="020F0302020204030204"/>
-        <a:ea typeface=""/>
-        <a:cs typeface=""/>
-        <a:font script="Jpan" typeface="ＭＳ Ｐゴシック"/>
-        <a:font script="Hang" typeface="맑은 고딕"/>
-        <a:font script="Hans" typeface="宋体"/>
-        <a:font script="Hant" typeface="新細明體"/>
-        <a:font script="Arab" typeface="Times New Roman"/>
-        <a:font script="Hebr" typeface="Times New Roman"/>
-        <a:font script="Thai" typeface="Angsana New"/>
-        <a:font script="Ethi" typeface="Nyala"/>
-        <a:font script="Beng" typeface="Vrinda"/>
-        <a:font script="Gujr" typeface="Shruti"/>
-        <a:font script="Khmr" typeface="MoolBoran"/>
-        <a:font script="Knda" typeface="Tunga"/>
-        <a:font script="Guru" typeface="Raavi"/>
-        <a:font script="Cans" typeface="Euphemia"/>
-        <a:font script="Cher" typeface="Plantagenet Cherokee"/>
-        <a:font script="Yiii" typeface="Microsoft Yi Baiti"/>
-        <a:font script="Tibt" typeface="Microsoft Himalaya"/>
-        <a:font script="Thaa" typeface="MV Boli"/>
-        <a:font script="Deva" typeface="Mangal"/>
-        <a:font script="Telu" typeface="Gautami"/>
-        <a:font script="Taml" typeface="Latha"/>
-        <a:font script="Syrc" typeface="Estrangelo Edessa"/>
-        <a:font script="Orya" typeface="Kalinga"/>
-        <a:font script="Mlym" typeface="Kartika"/>
-        <a:font script="Laoo" typeface="DokChampa"/>
-        <a:font script="Sinh" typeface="Iskoola Pota"/>
-        <a:font script="Mong" typeface="Mongolian Baiti"/>
-        <a:font script="Viet" typeface="Times New Roman"/>
-        <a:font script="Uigh" typeface="Microsoft Uighur"/>
-        <a:font script="Geor" typeface="Sylfaen"/>
-      </a:majorFont>
-      <a:minorFont>
-        <a:latin typeface="Calibri" panose="020F0502020204030204"/>
-        <a:ea typeface=""/>
-        <a:cs typeface=""/>
-        <a:font script="Jpan" typeface="ＭＳ Ｐゴシック"/>
-        <a:font script="Hang" typeface="맑은 고딕"/>
-        <a:font script="Hans" typeface="宋体"/>
-        <a:font script="Hant" typeface="新細明體"/>
-        <a:font script="Arab" typeface="Arial"/>
-        <a:font script="Hebr" typeface="Arial"/>
-        <a:font script="Thai" typeface="Cordia New"/>
-        <a:font script="Ethi" typeface="Nyala"/>
-        <a:font script="Beng" typeface="Vrinda"/>
-        <a:font script="Gujr" typeface="Shruti"/>
-        <a:font script="Khmr" typeface="DaunPenh"/>
-        <a:font script="Knda" typeface="Tunga"/>
-        <a:font script="Guru" typeface="Raavi"/>
-        <a:font script="Cans" typeface="Euphemia"/>
-        <a:font script="Cher" typeface="Plantagenet Cherokee"/>
-        <a:font script="Yiii" typeface="Microsoft Yi Baiti"/>
-        <a:font script="Tibt" typeface="Microsoft Himalaya"/>
-        <a:font script="Thaa" typeface="MV Boli"/>
-        <a:font script="Deva" typeface="Mangal"/>
-        <a:font script="Telu" typeface="Gautami"/>
-        <a:font script="Taml" typeface="Latha"/>
-        <a:font script="Syrc" typeface="Estrangelo Edessa"/>
-        <a:font script="Orya" typeface="Kalinga"/>
-        <a:font script="Mlym" typeface="Kartika"/>
-        <a:font script="Laoo" typeface="DokChampa"/>
-        <a:font script="Sinh" typeface="Iskoola Pota"/>
-        <a:font script="Mong" typeface="Mongolian Baiti"/>
-        <a:font script="Viet" typeface="Arial"/>
-        <a:font script="Uigh" typeface="Microsoft Uighur"/>
-        <a:font script="Geor" typeface="Sylfaen"/>
-      </a:minorFont>
-    </a:fontScheme>
-    <a:fmtScheme name="Office">
-      <a:fillStyleLst>
-        <a:solidFill>
-          <a:schemeClr val="phClr"/>
-        </a:solidFill>
-        <a:gradFill rotWithShape="1">
-          <a:gsLst>
-            <a:gs pos="0">
-              <a:schemeClr val="phClr">
-                <a:lumMod val="110000"/>
-                <a:satMod val="105000"/>
-                <a:tint val="67000"/>
-              </a:schemeClr>
-            </a:gs>
-            <a:gs pos="50000">
-              <a:schemeClr val="phClr">
-                <a:lumMod val="105000"/>
-                <a:satMod val="103000"/>
-                <a:tint val="73000"/>
-              </a:schemeClr>
-            </a:gs>
-            <a:gs pos="100000">
-              <a:schemeClr val="phClr">
-                <a:lumMod val="105000"/>
-                <a:satMod val="109000"/>
-                <a:tint val="81000"/>
-              </a:schemeClr>
-            </a:gs>
-          </a:gsLst>
-          <a:lin ang="5400000" scaled="0"/>
-        </a:gradFill>
-        <a:gradFill rotWithShape="1">
-          <a:gsLst>
-            <a:gs pos="0">
-              <a:schemeClr val="phClr">
-                <a:satMod val="103000"/>
-                <a:lumMod val="102000"/>
-                <a:tint val="94000"/>
-              </a:schemeClr>
-            </a:gs>
-            <a:gs pos="50000">
-              <a:schemeClr val="phClr">
-                <a:satMod val="110000"/>
-                <a:lumMod val="100000"/>
-                <a:shade val="100000"/>
-              </a:schemeClr>
-            </a:gs>
-            <a:gs pos="100000">
-              <a:schemeClr val="phClr">
-                <a:lumMod val="99000"/>
-                <a:satMod val="120000"/>
-                <a:shade val="78000"/>
-              </a:schemeClr>
-            </a:gs>
-          </a:gsLst>
-          <a:lin ang="5400000" scaled="0"/>
-        </a:gradFill>
-      </a:fillStyleLst>
-      <a:lnStyleLst>
-        <a:ln w="6350" cap="flat" cmpd="sng" algn="ctr">
-          <a:solidFill>
-            <a:schemeClr val="phClr"/>
-          </a:solidFill>
-          <a:prstDash val="solid"/>
-          <a:miter lim="800000"/>
-        </a:ln>
-        <a:ln w="12700" cap="flat" cmpd="sng" algn="ctr">
-          <a:solidFill>
-            <a:schemeClr val="phClr"/>
-          </a:solidFill>
-          <a:prstDash val="solid"/>
-          <a:miter lim="800000"/>
-        </a:ln>
-        <a:ln w="19050" cap="flat" cmpd="sng" algn="ctr">
-          <a:solidFill>
-            <a:schemeClr val="phClr"/>
-          </a:solidFill>
-          <a:prstDash val="solid"/>
-          <a:miter lim="800000"/>
-        </a:ln>
-      </a:lnStyleLst>
-      <a:effectStyleLst>
-        <a:effectStyle>
-          <a:effectLst/>
-        </a:effectStyle>
-        <a:effectStyle>
-          <a:effectLst/>
-        </a:effectStyle>
-        <a:effectStyle>
-          <a:effectLst>
-            <a:outerShdw blurRad="57150" dist="19050" dir="5400000" algn="ctr" rotWithShape="0">
-              <a:srgbClr val="000000">
-                <a:alpha val="63000"/>
-              </a:srgbClr>
-            </a:outerShdw>
-          </a:effectLst>
-        </a:effectStyle>
-      </a:effectStyleLst>
-      <a:bgFillStyleLst>
-        <a:solidFill>
-          <a:schemeClr val="phClr"/>
-        </a:solidFill>
-        <a:solidFill>
-          <a:schemeClr val="phClr">
-            <a:tint val="95000"/>
-            <a:satMod val="170000"/>
-          </a:schemeClr>
-        </a:solidFill>
-        <a:gradFill rotWithShape="1">
-          <a:gsLst>
-            <a:gs pos="0">
-              <a:schemeClr val="phClr">
-                <a:tint val="93000"/>
-                <a:satMod val="150000"/>
-                <a:shade val="98000"/>
-                <a:lumMod val="102000"/>
-              </a:schemeClr>
-            </a:gs>
-            <a:gs pos="50000">
-              <a:schemeClr val="phClr">
-                <a:tint val="98000"/>
-                <a:satMod val="130000"/>
-                <a:shade val="90000"/>
-                <a:lumMod val="103000"/>
-              </a:schemeClr>
-            </a:gs>
-            <a:gs pos="100000">
-              <a:schemeClr val="phClr">
-                <a:shade val="63000"/>
-                <a:satMod val="120000"/>
-              </a:schemeClr>
-            </a:gs>
-          </a:gsLst>
-          <a:lin ang="5400000" scaled="0"/>
-        </a:gradFill>
-      </a:bgFillStyleLst>
-    </a:fmtScheme>
-  </a:themeElements>
-  <a:objectDefaults/>
-  <a:extraClrSchemeLst/>
-  <a:extLst>
-    <a:ext uri="{05A4C25C-085E-4340-85A3-A5531E510DB2}">
-      <thm15:themeFamily xmlns:thm15="http://schemas.microsoft.com/office/thememl/2012/main" name="Office Theme" id="{62F939B6-93AF-4DB8-9C6B-D6C7DFDC589F}" vid="{4A3C46E8-61CC-4603-A589-7422A47A8E4A}"/>
-    </a:ext>
-  </a:extLst>
-</a:theme>
 </file>
</xml_diff>